<commit_message>
docs: añadido nuevas diapositivas
</commit_message>
<xml_diff>
--- a/documentacion proyecto/Presentacion_proyecto.pptx
+++ b/documentacion proyecto/Presentacion_proyecto.pptx
@@ -9,6 +9,9 @@
     <p:sldId id="257" r:id="rId3"/>
     <p:sldId id="258" r:id="rId4"/>
     <p:sldId id="259" r:id="rId5"/>
+    <p:sldId id="260" r:id="rId6"/>
+    <p:sldId id="261" r:id="rId7"/>
+    <p:sldId id="262" r:id="rId8"/>
   </p:sldIdLst>
   <p:sldSz cx="12192000" cy="6858000"/>
   <p:notesSz cx="6858000" cy="9144000"/>
@@ -107,6 +110,11 @@
       </a:defRPr>
     </a:lvl9pPr>
   </p:defaultTextStyle>
+  <p:extLst>
+    <p:ext uri="{EFAFB233-063F-42B5-8137-9DF3F51BA10A}">
+      <p15:sldGuideLst xmlns:p15="http://schemas.microsoft.com/office/powerpoint/2012/main"/>
+    </p:ext>
+  </p:extLst>
 </p:presentation>
 </file>
 
@@ -298,7 +306,7 @@
           <a:p>
             <a:fld id="{7DA38F49-B3E2-4BF0-BEC7-C30D34ABBB8D}" type="datetime1">
               <a:rPr lang="en-US" smtClean="0"/>
-              <a:t>5/11/2026</a:t>
+              <a:t>5/12/2026</a:t>
             </a:fld>
             <a:endParaRPr lang="en-US"/>
           </a:p>
@@ -404,6 +412,13 @@
             <a:noFill/>
           </a:ln>
         </p:spPr>
+        <p:txBody>
+          <a:bodyPr/>
+          <a:lstStyle/>
+          <a:p>
+            <a:endParaRPr lang="es-ES"/>
+          </a:p>
+        </p:txBody>
       </p:sp>
       <p:sp>
         <p:nvSpPr>
@@ -637,7 +652,7 @@
           <a:p>
             <a:fld id="{7DA38F49-B3E2-4BF0-BEC7-C30D34ABBB8D}" type="datetime1">
               <a:rPr lang="en-US" smtClean="0"/>
-              <a:t>5/11/2026</a:t>
+              <a:t>5/12/2026</a:t>
             </a:fld>
             <a:endParaRPr lang="en-US"/>
           </a:p>
@@ -1039,7 +1054,7 @@
           <a:p>
             <a:fld id="{7DA38F49-B3E2-4BF0-BEC7-C30D34ABBB8D}" type="datetime1">
               <a:rPr lang="en-US" smtClean="0"/>
-              <a:t>5/11/2026</a:t>
+              <a:t>5/12/2026</a:t>
             </a:fld>
             <a:endParaRPr lang="en-US"/>
           </a:p>
@@ -1376,7 +1391,7 @@
           <a:p>
             <a:fld id="{7DA38F49-B3E2-4BF0-BEC7-C30D34ABBB8D}" type="datetime1">
               <a:rPr lang="en-US" smtClean="0"/>
-              <a:t>5/11/2026</a:t>
+              <a:t>5/12/2026</a:t>
             </a:fld>
             <a:endParaRPr lang="en-US"/>
           </a:p>
@@ -1697,7 +1712,7 @@
           <a:p>
             <a:fld id="{7DA38F49-B3E2-4BF0-BEC7-C30D34ABBB8D}" type="datetime1">
               <a:rPr lang="en-US" smtClean="0"/>
-              <a:t>5/11/2026</a:t>
+              <a:t>5/12/2026</a:t>
             </a:fld>
             <a:endParaRPr lang="en-US"/>
           </a:p>
@@ -2094,7 +2109,7 @@
           <a:p>
             <a:fld id="{7DA38F49-B3E2-4BF0-BEC7-C30D34ABBB8D}" type="datetime1">
               <a:rPr lang="en-US" smtClean="0"/>
-              <a:t>5/11/2026</a:t>
+              <a:t>5/12/2026</a:t>
             </a:fld>
             <a:endParaRPr lang="en-US"/>
           </a:p>
@@ -2352,7 +2367,7 @@
           <a:p>
             <a:fld id="{7DA38F49-B3E2-4BF0-BEC7-C30D34ABBB8D}" type="datetime1">
               <a:rPr lang="en-US" smtClean="0"/>
-              <a:t>5/11/2026</a:t>
+              <a:t>5/12/2026</a:t>
             </a:fld>
             <a:endParaRPr lang="en-US"/>
           </a:p>
@@ -2615,7 +2630,7 @@
           <a:p>
             <a:fld id="{7DA38F49-B3E2-4BF0-BEC7-C30D34ABBB8D}" type="datetime1">
               <a:rPr lang="en-US" smtClean="0"/>
-              <a:t>5/11/2026</a:t>
+              <a:t>5/12/2026</a:t>
             </a:fld>
             <a:endParaRPr lang="en-US"/>
           </a:p>
@@ -2878,7 +2893,7 @@
           <a:p>
             <a:fld id="{7DA38F49-B3E2-4BF0-BEC7-C30D34ABBB8D}" type="datetime1">
               <a:rPr lang="en-US" smtClean="0"/>
-              <a:t>5/11/2026</a:t>
+              <a:t>5/12/2026</a:t>
             </a:fld>
             <a:endParaRPr lang="en-US"/>
           </a:p>
@@ -3208,7 +3223,7 @@
           <a:p>
             <a:fld id="{7DA38F49-B3E2-4BF0-BEC7-C30D34ABBB8D}" type="datetime1">
               <a:rPr lang="en-US" smtClean="0"/>
-              <a:t>5/11/2026</a:t>
+              <a:t>5/12/2026</a:t>
             </a:fld>
             <a:endParaRPr lang="en-US"/>
           </a:p>
@@ -3532,7 +3547,7 @@
           <a:p>
             <a:fld id="{7DA38F49-B3E2-4BF0-BEC7-C30D34ABBB8D}" type="datetime1">
               <a:rPr lang="en-US" smtClean="0"/>
-              <a:t>5/11/2026</a:t>
+              <a:t>5/12/2026</a:t>
             </a:fld>
             <a:endParaRPr lang="en-US"/>
           </a:p>
@@ -3990,7 +4005,7 @@
           <a:p>
             <a:fld id="{7DA38F49-B3E2-4BF0-BEC7-C30D34ABBB8D}" type="datetime1">
               <a:rPr lang="en-US" smtClean="0"/>
-              <a:t>5/11/2026</a:t>
+              <a:t>5/12/2026</a:t>
             </a:fld>
             <a:endParaRPr lang="en-US"/>
           </a:p>
@@ -4196,7 +4211,7 @@
           <a:p>
             <a:fld id="{7DA38F49-B3E2-4BF0-BEC7-C30D34ABBB8D}" type="datetime1">
               <a:rPr lang="en-US" smtClean="0"/>
-              <a:t>5/11/2026</a:t>
+              <a:t>5/12/2026</a:t>
             </a:fld>
             <a:endParaRPr lang="en-US"/>
           </a:p>
@@ -4374,7 +4389,7 @@
           <a:p>
             <a:fld id="{7DA38F49-B3E2-4BF0-BEC7-C30D34ABBB8D}" type="datetime1">
               <a:rPr lang="en-US" smtClean="0"/>
-              <a:t>5/11/2026</a:t>
+              <a:t>5/12/2026</a:t>
             </a:fld>
             <a:endParaRPr lang="en-US"/>
           </a:p>
@@ -4708,7 +4723,7 @@
           <a:p>
             <a:fld id="{7DA38F49-B3E2-4BF0-BEC7-C30D34ABBB8D}" type="datetime1">
               <a:rPr lang="en-US" smtClean="0"/>
-              <a:t>5/11/2026</a:t>
+              <a:t>5/12/2026</a:t>
             </a:fld>
             <a:endParaRPr lang="en-US"/>
           </a:p>
@@ -5054,7 +5069,7 @@
           <a:p>
             <a:fld id="{7DA38F49-B3E2-4BF0-BEC7-C30D34ABBB8D}" type="datetime1">
               <a:rPr lang="en-US" smtClean="0"/>
-              <a:t>5/11/2026</a:t>
+              <a:t>5/12/2026</a:t>
             </a:fld>
             <a:endParaRPr lang="en-US"/>
           </a:p>
@@ -5299,6 +5314,13 @@
               <a:noFill/>
             </a:ln>
           </p:spPr>
+          <p:txBody>
+            <a:bodyPr/>
+            <a:lstStyle/>
+            <a:p>
+              <a:endParaRPr lang="es-ES"/>
+            </a:p>
+          </p:txBody>
         </p:sp>
         <p:sp>
           <p:nvSpPr>
@@ -5365,6 +5387,13 @@
               <a:noFill/>
             </a:ln>
           </p:spPr>
+          <p:txBody>
+            <a:bodyPr/>
+            <a:lstStyle/>
+            <a:p>
+              <a:endParaRPr lang="es-ES"/>
+            </a:p>
+          </p:txBody>
         </p:sp>
         <p:sp>
           <p:nvSpPr>
@@ -5436,6 +5465,13 @@
               <a:noFill/>
             </a:ln>
           </p:spPr>
+          <p:txBody>
+            <a:bodyPr/>
+            <a:lstStyle/>
+            <a:p>
+              <a:endParaRPr lang="es-ES"/>
+            </a:p>
+          </p:txBody>
         </p:sp>
         <p:sp>
           <p:nvSpPr>
@@ -5487,6 +5523,13 @@
               <a:noFill/>
             </a:ln>
           </p:spPr>
+          <p:txBody>
+            <a:bodyPr/>
+            <a:lstStyle/>
+            <a:p>
+              <a:endParaRPr lang="es-ES"/>
+            </a:p>
+          </p:txBody>
         </p:sp>
         <p:sp>
           <p:nvSpPr>
@@ -5573,6 +5616,13 @@
               <a:noFill/>
             </a:ln>
           </p:spPr>
+          <p:txBody>
+            <a:bodyPr/>
+            <a:lstStyle/>
+            <a:p>
+              <a:endParaRPr lang="es-ES"/>
+            </a:p>
+          </p:txBody>
         </p:sp>
         <p:sp>
           <p:nvSpPr>
@@ -5654,6 +5704,13 @@
               <a:noFill/>
             </a:ln>
           </p:spPr>
+          <p:txBody>
+            <a:bodyPr/>
+            <a:lstStyle/>
+            <a:p>
+              <a:endParaRPr lang="es-ES"/>
+            </a:p>
+          </p:txBody>
         </p:sp>
         <p:sp>
           <p:nvSpPr>
@@ -5715,6 +5772,13 @@
               <a:noFill/>
             </a:ln>
           </p:spPr>
+          <p:txBody>
+            <a:bodyPr/>
+            <a:lstStyle/>
+            <a:p>
+              <a:endParaRPr lang="es-ES"/>
+            </a:p>
+          </p:txBody>
         </p:sp>
         <p:sp>
           <p:nvSpPr>
@@ -5796,6 +5860,13 @@
               <a:noFill/>
             </a:ln>
           </p:spPr>
+          <p:txBody>
+            <a:bodyPr/>
+            <a:lstStyle/>
+            <a:p>
+              <a:endParaRPr lang="es-ES"/>
+            </a:p>
+          </p:txBody>
         </p:sp>
         <p:sp>
           <p:nvSpPr>
@@ -5912,6 +5983,13 @@
               <a:noFill/>
             </a:ln>
           </p:spPr>
+          <p:txBody>
+            <a:bodyPr/>
+            <a:lstStyle/>
+            <a:p>
+              <a:endParaRPr lang="es-ES"/>
+            </a:p>
+          </p:txBody>
         </p:sp>
         <p:sp>
           <p:nvSpPr>
@@ -5963,6 +6041,13 @@
               <a:noFill/>
             </a:ln>
           </p:spPr>
+          <p:txBody>
+            <a:bodyPr/>
+            <a:lstStyle/>
+            <a:p>
+              <a:endParaRPr lang="es-ES"/>
+            </a:p>
+          </p:txBody>
         </p:sp>
         <p:sp>
           <p:nvSpPr>
@@ -6024,6 +6109,13 @@
               <a:noFill/>
             </a:ln>
           </p:spPr>
+          <p:txBody>
+            <a:bodyPr/>
+            <a:lstStyle/>
+            <a:p>
+              <a:endParaRPr lang="es-ES"/>
+            </a:p>
+          </p:txBody>
         </p:sp>
         <p:sp>
           <p:nvSpPr>
@@ -6095,6 +6187,13 @@
               <a:noFill/>
             </a:ln>
           </p:spPr>
+          <p:txBody>
+            <a:bodyPr/>
+            <a:lstStyle/>
+            <a:p>
+              <a:endParaRPr lang="es-ES"/>
+            </a:p>
+          </p:txBody>
         </p:sp>
       </p:grpSp>
       <p:grpSp>
@@ -6214,6 +6313,13 @@
               <a:noFill/>
             </a:ln>
           </p:spPr>
+          <p:txBody>
+            <a:bodyPr/>
+            <a:lstStyle/>
+            <a:p>
+              <a:endParaRPr lang="es-ES"/>
+            </a:p>
+          </p:txBody>
         </p:sp>
         <p:sp>
           <p:nvSpPr>
@@ -6283,6 +6389,13 @@
               <a:noFill/>
             </a:ln>
           </p:spPr>
+          <p:txBody>
+            <a:bodyPr/>
+            <a:lstStyle/>
+            <a:p>
+              <a:endParaRPr lang="es-ES"/>
+            </a:p>
+          </p:txBody>
         </p:sp>
         <p:sp>
           <p:nvSpPr>
@@ -6352,6 +6465,13 @@
               <a:noFill/>
             </a:ln>
           </p:spPr>
+          <p:txBody>
+            <a:bodyPr/>
+            <a:lstStyle/>
+            <a:p>
+              <a:endParaRPr lang="es-ES"/>
+            </a:p>
+          </p:txBody>
         </p:sp>
         <p:sp>
           <p:nvSpPr>
@@ -6436,6 +6556,13 @@
               <a:noFill/>
             </a:ln>
           </p:spPr>
+          <p:txBody>
+            <a:bodyPr/>
+            <a:lstStyle/>
+            <a:p>
+              <a:endParaRPr lang="es-ES"/>
+            </a:p>
+          </p:txBody>
         </p:sp>
         <p:sp>
           <p:nvSpPr>
@@ -6530,6 +6657,13 @@
               <a:noFill/>
             </a:ln>
           </p:spPr>
+          <p:txBody>
+            <a:bodyPr/>
+            <a:lstStyle/>
+            <a:p>
+              <a:endParaRPr lang="es-ES"/>
+            </a:p>
+          </p:txBody>
         </p:sp>
         <p:sp>
           <p:nvSpPr>
@@ -6579,6 +6713,13 @@
               <a:noFill/>
             </a:ln>
           </p:spPr>
+          <p:txBody>
+            <a:bodyPr/>
+            <a:lstStyle/>
+            <a:p>
+              <a:endParaRPr lang="es-ES"/>
+            </a:p>
+          </p:txBody>
         </p:sp>
         <p:sp>
           <p:nvSpPr>
@@ -6643,6 +6784,13 @@
               <a:noFill/>
             </a:ln>
           </p:spPr>
+          <p:txBody>
+            <a:bodyPr/>
+            <a:lstStyle/>
+            <a:p>
+              <a:endParaRPr lang="es-ES"/>
+            </a:p>
+          </p:txBody>
         </p:sp>
         <p:sp>
           <p:nvSpPr>
@@ -6752,6 +6900,13 @@
               <a:noFill/>
             </a:ln>
           </p:spPr>
+          <p:txBody>
+            <a:bodyPr/>
+            <a:lstStyle/>
+            <a:p>
+              <a:endParaRPr lang="es-ES"/>
+            </a:p>
+          </p:txBody>
         </p:sp>
         <p:sp>
           <p:nvSpPr>
@@ -6801,6 +6956,13 @@
               <a:noFill/>
             </a:ln>
           </p:spPr>
+          <p:txBody>
+            <a:bodyPr/>
+            <a:lstStyle/>
+            <a:p>
+              <a:endParaRPr lang="es-ES"/>
+            </a:p>
+          </p:txBody>
         </p:sp>
         <p:sp>
           <p:nvSpPr>
@@ -6870,6 +7032,13 @@
               <a:noFill/>
             </a:ln>
           </p:spPr>
+          <p:txBody>
+            <a:bodyPr/>
+            <a:lstStyle/>
+            <a:p>
+              <a:endParaRPr lang="es-ES"/>
+            </a:p>
+          </p:txBody>
         </p:sp>
         <p:sp>
           <p:nvSpPr>
@@ -6934,6 +7103,13 @@
               <a:noFill/>
             </a:ln>
           </p:spPr>
+          <p:txBody>
+            <a:bodyPr/>
+            <a:lstStyle/>
+            <a:p>
+              <a:endParaRPr lang="es-ES"/>
+            </a:p>
+          </p:txBody>
         </p:sp>
         <p:sp>
           <p:nvSpPr>
@@ -7003,6 +7179,13 @@
               <a:noFill/>
             </a:ln>
           </p:spPr>
+          <p:txBody>
+            <a:bodyPr/>
+            <a:lstStyle/>
+            <a:p>
+              <a:endParaRPr lang="es-ES"/>
+            </a:p>
+          </p:txBody>
         </p:sp>
       </p:grpSp>
       <p:sp>
@@ -7041,6 +7224,13 @@
             <a:schemeClr val="lt1"/>
           </a:fontRef>
         </p:style>
+        <p:txBody>
+          <a:bodyPr/>
+          <a:lstStyle/>
+          <a:p>
+            <a:endParaRPr lang="es-ES"/>
+          </a:p>
+        </p:txBody>
       </p:sp>
       <p:sp>
         <p:nvSpPr>
@@ -7172,7 +7362,7 @@
           <a:p>
             <a:fld id="{7DA38F49-B3E2-4BF0-BEC7-C30D34ABBB8D}" type="datetime1">
               <a:rPr lang="en-US" smtClean="0"/>
-              <a:t>5/11/2026</a:t>
+              <a:t>5/12/2026</a:t>
             </a:fld>
             <a:endParaRPr lang="en-US"/>
           </a:p>
@@ -9037,6 +9227,1449 @@
 </p:sld>
 </file>
 
+<file path=ppt/slides/slide5.xml><?xml version="1.0" encoding="utf-8"?>
+<p:sld xmlns:a="http://schemas.openxmlformats.org/drawingml/2006/main" xmlns:r="http://schemas.openxmlformats.org/officeDocument/2006/relationships" xmlns:p="http://schemas.openxmlformats.org/presentationml/2006/main">
+  <p:cSld>
+    <p:spTree>
+      <p:nvGrpSpPr>
+        <p:cNvPr id="1" name=""/>
+        <p:cNvGrpSpPr/>
+        <p:nvPr/>
+      </p:nvGrpSpPr>
+      <p:grpSpPr>
+        <a:xfrm>
+          <a:off x="0" y="0"/>
+          <a:ext cx="0" cy="0"/>
+          <a:chOff x="0" y="0"/>
+          <a:chExt cx="0" cy="0"/>
+        </a:xfrm>
+      </p:grpSpPr>
+      <p:sp>
+        <p:nvSpPr>
+          <p:cNvPr id="2" name="Título 1">
+            <a:extLst>
+              <a:ext uri="{FF2B5EF4-FFF2-40B4-BE49-F238E27FC236}">
+                <a16:creationId xmlns:a16="http://schemas.microsoft.com/office/drawing/2014/main" id="{06A4F802-8D91-943F-5C1D-D5F551B715DE}"/>
+              </a:ext>
+            </a:extLst>
+          </p:cNvPr>
+          <p:cNvSpPr>
+            <a:spLocks noGrp="1"/>
+          </p:cNvSpPr>
+          <p:nvPr>
+            <p:ph type="title"/>
+          </p:nvPr>
+        </p:nvSpPr>
+        <p:spPr/>
+        <p:txBody>
+          <a:bodyPr/>
+          <a:lstStyle/>
+          <a:p>
+            <a:r>
+              <a:rPr lang="es-ES" dirty="0"/>
+              <a:t>Arquitectura del sistema</a:t>
+            </a:r>
+          </a:p>
+        </p:txBody>
+      </p:sp>
+      <p:sp>
+        <p:nvSpPr>
+          <p:cNvPr id="4" name="CuadroTexto 3">
+            <a:extLst>
+              <a:ext uri="{FF2B5EF4-FFF2-40B4-BE49-F238E27FC236}">
+                <a16:creationId xmlns:a16="http://schemas.microsoft.com/office/drawing/2014/main" id="{7B09E4D7-60AD-CA64-0775-967B20737924}"/>
+              </a:ext>
+            </a:extLst>
+          </p:cNvPr>
+          <p:cNvSpPr txBox="1"/>
+          <p:nvPr/>
+        </p:nvSpPr>
+        <p:spPr>
+          <a:xfrm>
+            <a:off x="1304269" y="2323651"/>
+            <a:ext cx="1933076" cy="646331"/>
+          </a:xfrm>
+          <a:prstGeom prst="rect">
+            <a:avLst/>
+          </a:prstGeom>
+          <a:solidFill>
+            <a:srgbClr val="FFF7ED"/>
+          </a:solidFill>
+          <a:ln w="28575">
+            <a:solidFill>
+              <a:srgbClr val="FED7AA"/>
+            </a:solidFill>
+          </a:ln>
+        </p:spPr>
+        <p:txBody>
+          <a:bodyPr wrap="square" rtlCol="0">
+            <a:spAutoFit/>
+          </a:bodyPr>
+          <a:lstStyle/>
+          <a:p>
+            <a:pPr algn="ctr"/>
+            <a:r>
+              <a:rPr lang="es-ES" dirty="0"/>
+              <a:t>Navegador</a:t>
+            </a:r>
+          </a:p>
+          <a:p>
+            <a:pPr algn="ctr"/>
+            <a:r>
+              <a:rPr lang="es-ES" dirty="0"/>
+              <a:t>Cliente</a:t>
+            </a:r>
+          </a:p>
+        </p:txBody>
+      </p:sp>
+      <p:sp>
+        <p:nvSpPr>
+          <p:cNvPr id="5" name="CuadroTexto 4">
+            <a:extLst>
+              <a:ext uri="{FF2B5EF4-FFF2-40B4-BE49-F238E27FC236}">
+                <a16:creationId xmlns:a16="http://schemas.microsoft.com/office/drawing/2014/main" id="{343AC271-8B97-0CC9-C3B2-60A6A7F2489B}"/>
+              </a:ext>
+            </a:extLst>
+          </p:cNvPr>
+          <p:cNvSpPr txBox="1"/>
+          <p:nvPr/>
+        </p:nvSpPr>
+        <p:spPr>
+          <a:xfrm>
+            <a:off x="4466216" y="2323651"/>
+            <a:ext cx="3259567" cy="646331"/>
+          </a:xfrm>
+          <a:prstGeom prst="rect">
+            <a:avLst/>
+          </a:prstGeom>
+          <a:solidFill>
+            <a:srgbClr val="EFF6FF"/>
+          </a:solidFill>
+          <a:ln w="28575">
+            <a:solidFill>
+              <a:srgbClr val="BFDBFE"/>
+            </a:solidFill>
+          </a:ln>
+        </p:spPr>
+        <p:txBody>
+          <a:bodyPr wrap="square" rtlCol="0">
+            <a:spAutoFit/>
+          </a:bodyPr>
+          <a:lstStyle/>
+          <a:p>
+            <a:pPr algn="ctr"/>
+            <a:r>
+              <a:rPr lang="es-ES" dirty="0"/>
+              <a:t>Servidor Next.js</a:t>
+            </a:r>
+          </a:p>
+          <a:p>
+            <a:pPr algn="ctr"/>
+            <a:r>
+              <a:rPr lang="es-ES" dirty="0"/>
+              <a:t>Frontend + Backend (SSR)</a:t>
+            </a:r>
+          </a:p>
+        </p:txBody>
+      </p:sp>
+      <p:sp>
+        <p:nvSpPr>
+          <p:cNvPr id="6" name="CuadroTexto 5">
+            <a:extLst>
+              <a:ext uri="{FF2B5EF4-FFF2-40B4-BE49-F238E27FC236}">
+                <a16:creationId xmlns:a16="http://schemas.microsoft.com/office/drawing/2014/main" id="{D1618C52-FA9C-BB9E-2794-AE01FCBDB3C6}"/>
+              </a:ext>
+            </a:extLst>
+          </p:cNvPr>
+          <p:cNvSpPr txBox="1"/>
+          <p:nvPr/>
+        </p:nvSpPr>
+        <p:spPr>
+          <a:xfrm>
+            <a:off x="8967354" y="2323652"/>
+            <a:ext cx="2317173" cy="646331"/>
+          </a:xfrm>
+          <a:prstGeom prst="rect">
+            <a:avLst/>
+          </a:prstGeom>
+          <a:solidFill>
+            <a:srgbClr val="EFF6FF"/>
+          </a:solidFill>
+          <a:ln w="28575">
+            <a:solidFill>
+              <a:srgbClr val="BFDBFE"/>
+            </a:solidFill>
+          </a:ln>
+        </p:spPr>
+        <p:txBody>
+          <a:bodyPr wrap="square" rtlCol="0">
+            <a:spAutoFit/>
+          </a:bodyPr>
+          <a:lstStyle>
+            <a:defPPr>
+              <a:defRPr lang="en-US"/>
+            </a:defPPr>
+            <a:lvl1pPr algn="ctr">
+              <a:defRPr/>
+            </a:lvl1pPr>
+          </a:lstStyle>
+          <a:p>
+            <a:r>
+              <a:rPr lang="es-ES" dirty="0"/>
+              <a:t>Base de Datos</a:t>
+            </a:r>
+          </a:p>
+          <a:p>
+            <a:r>
+              <a:rPr lang="es-ES" dirty="0" err="1"/>
+              <a:t>NeonDB</a:t>
+            </a:r>
+            <a:r>
+              <a:rPr lang="es-ES" dirty="0"/>
+              <a:t> + </a:t>
+            </a:r>
+            <a:r>
+              <a:rPr lang="es-ES" dirty="0" err="1"/>
+              <a:t>Postgres</a:t>
+            </a:r>
+            <a:endParaRPr lang="es-ES" dirty="0"/>
+          </a:p>
+        </p:txBody>
+      </p:sp>
+      <p:cxnSp>
+        <p:nvCxnSpPr>
+          <p:cNvPr id="8" name="Conector recto de flecha 7">
+            <a:extLst>
+              <a:ext uri="{FF2B5EF4-FFF2-40B4-BE49-F238E27FC236}">
+                <a16:creationId xmlns:a16="http://schemas.microsoft.com/office/drawing/2014/main" id="{3C16CBAD-DD6E-9F88-4AB2-068F96BB93C3}"/>
+              </a:ext>
+            </a:extLst>
+          </p:cNvPr>
+          <p:cNvCxnSpPr>
+            <a:cxnSpLocks/>
+          </p:cNvCxnSpPr>
+          <p:nvPr/>
+        </p:nvCxnSpPr>
+        <p:spPr>
+          <a:xfrm>
+            <a:off x="3237345" y="2504209"/>
+            <a:ext cx="1228871" cy="0"/>
+          </a:xfrm>
+          <a:prstGeom prst="straightConnector1">
+            <a:avLst/>
+          </a:prstGeom>
+          <a:ln w="19050">
+            <a:solidFill>
+              <a:schemeClr val="accent6">
+                <a:lumMod val="60000"/>
+                <a:lumOff val="40000"/>
+              </a:schemeClr>
+            </a:solidFill>
+            <a:tailEnd type="triangle"/>
+          </a:ln>
+        </p:spPr>
+        <p:style>
+          <a:lnRef idx="1">
+            <a:schemeClr val="accent1"/>
+          </a:lnRef>
+          <a:fillRef idx="0">
+            <a:schemeClr val="accent1"/>
+          </a:fillRef>
+          <a:effectRef idx="0">
+            <a:schemeClr val="accent1"/>
+          </a:effectRef>
+          <a:fontRef idx="minor">
+            <a:schemeClr val="tx1"/>
+          </a:fontRef>
+        </p:style>
+      </p:cxnSp>
+      <p:cxnSp>
+        <p:nvCxnSpPr>
+          <p:cNvPr id="11" name="Conector recto de flecha 10">
+            <a:extLst>
+              <a:ext uri="{FF2B5EF4-FFF2-40B4-BE49-F238E27FC236}">
+                <a16:creationId xmlns:a16="http://schemas.microsoft.com/office/drawing/2014/main" id="{51A0DA3D-38FD-6460-94ED-0C14D6FC3C40}"/>
+              </a:ext>
+            </a:extLst>
+          </p:cNvPr>
+          <p:cNvCxnSpPr/>
+          <p:nvPr/>
+        </p:nvCxnSpPr>
+        <p:spPr>
+          <a:xfrm flipH="1">
+            <a:off x="3237345" y="2847109"/>
+            <a:ext cx="1228871" cy="0"/>
+          </a:xfrm>
+          <a:prstGeom prst="straightConnector1">
+            <a:avLst/>
+          </a:prstGeom>
+          <a:ln w="28575">
+            <a:tailEnd type="triangle"/>
+          </a:ln>
+        </p:spPr>
+        <p:style>
+          <a:lnRef idx="1">
+            <a:schemeClr val="accent1"/>
+          </a:lnRef>
+          <a:fillRef idx="0">
+            <a:schemeClr val="accent1"/>
+          </a:fillRef>
+          <a:effectRef idx="0">
+            <a:schemeClr val="accent1"/>
+          </a:effectRef>
+          <a:fontRef idx="minor">
+            <a:schemeClr val="tx1"/>
+          </a:fontRef>
+        </p:style>
+      </p:cxnSp>
+      <p:cxnSp>
+        <p:nvCxnSpPr>
+          <p:cNvPr id="12" name="Conector recto de flecha 11">
+            <a:extLst>
+              <a:ext uri="{FF2B5EF4-FFF2-40B4-BE49-F238E27FC236}">
+                <a16:creationId xmlns:a16="http://schemas.microsoft.com/office/drawing/2014/main" id="{5F0F16B4-A0A7-6086-6494-DE69AB4385FF}"/>
+              </a:ext>
+            </a:extLst>
+          </p:cNvPr>
+          <p:cNvCxnSpPr>
+            <a:cxnSpLocks/>
+          </p:cNvCxnSpPr>
+          <p:nvPr/>
+        </p:nvCxnSpPr>
+        <p:spPr>
+          <a:xfrm>
+            <a:off x="7738483" y="2504209"/>
+            <a:ext cx="1228871" cy="0"/>
+          </a:xfrm>
+          <a:prstGeom prst="straightConnector1">
+            <a:avLst/>
+          </a:prstGeom>
+          <a:ln w="19050">
+            <a:solidFill>
+              <a:schemeClr val="accent6">
+                <a:lumMod val="60000"/>
+                <a:lumOff val="40000"/>
+              </a:schemeClr>
+            </a:solidFill>
+            <a:tailEnd type="triangle"/>
+          </a:ln>
+        </p:spPr>
+        <p:style>
+          <a:lnRef idx="1">
+            <a:schemeClr val="accent1"/>
+          </a:lnRef>
+          <a:fillRef idx="0">
+            <a:schemeClr val="accent1"/>
+          </a:fillRef>
+          <a:effectRef idx="0">
+            <a:schemeClr val="accent1"/>
+          </a:effectRef>
+          <a:fontRef idx="minor">
+            <a:schemeClr val="tx1"/>
+          </a:fontRef>
+        </p:style>
+      </p:cxnSp>
+      <p:cxnSp>
+        <p:nvCxnSpPr>
+          <p:cNvPr id="13" name="Conector recto de flecha 12">
+            <a:extLst>
+              <a:ext uri="{FF2B5EF4-FFF2-40B4-BE49-F238E27FC236}">
+                <a16:creationId xmlns:a16="http://schemas.microsoft.com/office/drawing/2014/main" id="{989BFAF5-22D5-DDC9-4AA6-1709D17F9F06}"/>
+              </a:ext>
+            </a:extLst>
+          </p:cNvPr>
+          <p:cNvCxnSpPr/>
+          <p:nvPr/>
+        </p:nvCxnSpPr>
+        <p:spPr>
+          <a:xfrm flipH="1">
+            <a:off x="7725783" y="2847109"/>
+            <a:ext cx="1228871" cy="0"/>
+          </a:xfrm>
+          <a:prstGeom prst="straightConnector1">
+            <a:avLst/>
+          </a:prstGeom>
+          <a:ln w="28575">
+            <a:tailEnd type="triangle"/>
+          </a:ln>
+        </p:spPr>
+        <p:style>
+          <a:lnRef idx="1">
+            <a:schemeClr val="accent1"/>
+          </a:lnRef>
+          <a:fillRef idx="0">
+            <a:schemeClr val="accent1"/>
+          </a:fillRef>
+          <a:effectRef idx="0">
+            <a:schemeClr val="accent1"/>
+          </a:effectRef>
+          <a:fontRef idx="minor">
+            <a:schemeClr val="tx1"/>
+          </a:fontRef>
+        </p:style>
+      </p:cxnSp>
+      <p:sp>
+        <p:nvSpPr>
+          <p:cNvPr id="14" name="CuadroTexto 13">
+            <a:extLst>
+              <a:ext uri="{FF2B5EF4-FFF2-40B4-BE49-F238E27FC236}">
+                <a16:creationId xmlns:a16="http://schemas.microsoft.com/office/drawing/2014/main" id="{1DB45EAB-9F14-463E-425D-A741702F6B40}"/>
+              </a:ext>
+            </a:extLst>
+          </p:cNvPr>
+          <p:cNvSpPr txBox="1"/>
+          <p:nvPr/>
+        </p:nvSpPr>
+        <p:spPr>
+          <a:xfrm>
+            <a:off x="5129461" y="3702179"/>
+            <a:ext cx="1933076" cy="369332"/>
+          </a:xfrm>
+          <a:prstGeom prst="rect">
+            <a:avLst/>
+          </a:prstGeom>
+          <a:solidFill>
+            <a:srgbClr val="FFF7ED"/>
+          </a:solidFill>
+          <a:ln w="28575">
+            <a:solidFill>
+              <a:srgbClr val="FED7AA"/>
+            </a:solidFill>
+          </a:ln>
+        </p:spPr>
+        <p:txBody>
+          <a:bodyPr wrap="square" rtlCol="0">
+            <a:spAutoFit/>
+          </a:bodyPr>
+          <a:lstStyle/>
+          <a:p>
+            <a:pPr algn="ctr"/>
+            <a:r>
+              <a:rPr lang="es-ES" dirty="0" err="1"/>
+              <a:t>Printer</a:t>
+            </a:r>
+            <a:r>
+              <a:rPr lang="es-ES" dirty="0"/>
+              <a:t> Server</a:t>
+            </a:r>
+          </a:p>
+        </p:txBody>
+      </p:sp>
+      <p:cxnSp>
+        <p:nvCxnSpPr>
+          <p:cNvPr id="16" name="Conector recto de flecha 15">
+            <a:extLst>
+              <a:ext uri="{FF2B5EF4-FFF2-40B4-BE49-F238E27FC236}">
+                <a16:creationId xmlns:a16="http://schemas.microsoft.com/office/drawing/2014/main" id="{F298634F-577E-204C-F372-1FE59E555781}"/>
+              </a:ext>
+            </a:extLst>
+          </p:cNvPr>
+          <p:cNvCxnSpPr>
+            <a:stCxn id="5" idx="2"/>
+            <a:endCxn id="14" idx="0"/>
+          </p:cNvCxnSpPr>
+          <p:nvPr/>
+        </p:nvCxnSpPr>
+        <p:spPr>
+          <a:xfrm flipH="1">
+            <a:off x="6095999" y="2969982"/>
+            <a:ext cx="1" cy="732197"/>
+          </a:xfrm>
+          <a:prstGeom prst="straightConnector1">
+            <a:avLst/>
+          </a:prstGeom>
+          <a:ln w="28575">
+            <a:solidFill>
+              <a:srgbClr val="78716C"/>
+            </a:solidFill>
+            <a:tailEnd type="triangle"/>
+          </a:ln>
+        </p:spPr>
+        <p:style>
+          <a:lnRef idx="1">
+            <a:schemeClr val="accent1"/>
+          </a:lnRef>
+          <a:fillRef idx="0">
+            <a:schemeClr val="accent1"/>
+          </a:fillRef>
+          <a:effectRef idx="0">
+            <a:schemeClr val="accent1"/>
+          </a:effectRef>
+          <a:fontRef idx="minor">
+            <a:schemeClr val="tx1"/>
+          </a:fontRef>
+        </p:style>
+      </p:cxnSp>
+      <p:sp>
+        <p:nvSpPr>
+          <p:cNvPr id="17" name="CuadroTexto 16">
+            <a:extLst>
+              <a:ext uri="{FF2B5EF4-FFF2-40B4-BE49-F238E27FC236}">
+                <a16:creationId xmlns:a16="http://schemas.microsoft.com/office/drawing/2014/main" id="{B1ED5692-36A5-32C3-787E-67CE3C49A677}"/>
+              </a:ext>
+            </a:extLst>
+          </p:cNvPr>
+          <p:cNvSpPr txBox="1"/>
+          <p:nvPr/>
+        </p:nvSpPr>
+        <p:spPr>
+          <a:xfrm>
+            <a:off x="6192982" y="3231573"/>
+            <a:ext cx="966355" cy="369332"/>
+          </a:xfrm>
+          <a:prstGeom prst="rect">
+            <a:avLst/>
+          </a:prstGeom>
+          <a:noFill/>
+        </p:spPr>
+        <p:txBody>
+          <a:bodyPr wrap="square" rtlCol="0">
+            <a:spAutoFit/>
+          </a:bodyPr>
+          <a:lstStyle/>
+          <a:p>
+            <a:r>
+              <a:rPr lang="es-ES" b="1" dirty="0">
+                <a:solidFill>
+                  <a:srgbClr val="78716C"/>
+                </a:solidFill>
+              </a:rPr>
+              <a:t>HTTP</a:t>
+            </a:r>
+          </a:p>
+        </p:txBody>
+      </p:sp>
+      <p:sp>
+        <p:nvSpPr>
+          <p:cNvPr id="18" name="CuadroTexto 17">
+            <a:extLst>
+              <a:ext uri="{FF2B5EF4-FFF2-40B4-BE49-F238E27FC236}">
+                <a16:creationId xmlns:a16="http://schemas.microsoft.com/office/drawing/2014/main" id="{92CB5C31-D134-9E77-6E39-C6E73A6102BA}"/>
+              </a:ext>
+            </a:extLst>
+          </p:cNvPr>
+          <p:cNvSpPr txBox="1"/>
+          <p:nvPr/>
+        </p:nvSpPr>
+        <p:spPr>
+          <a:xfrm>
+            <a:off x="3534023" y="4803707"/>
+            <a:ext cx="1933076" cy="646331"/>
+          </a:xfrm>
+          <a:prstGeom prst="rect">
+            <a:avLst/>
+          </a:prstGeom>
+          <a:solidFill>
+            <a:srgbClr val="FFF7ED"/>
+          </a:solidFill>
+          <a:ln w="28575">
+            <a:solidFill>
+              <a:srgbClr val="FED7AA"/>
+            </a:solidFill>
+          </a:ln>
+        </p:spPr>
+        <p:txBody>
+          <a:bodyPr wrap="square" rtlCol="0">
+            <a:spAutoFit/>
+          </a:bodyPr>
+          <a:lstStyle/>
+          <a:p>
+            <a:pPr algn="ctr"/>
+            <a:r>
+              <a:rPr lang="es-ES" dirty="0"/>
+              <a:t>Impresora térmica</a:t>
+            </a:r>
+          </a:p>
+        </p:txBody>
+      </p:sp>
+      <p:sp>
+        <p:nvSpPr>
+          <p:cNvPr id="19" name="CuadroTexto 18">
+            <a:extLst>
+              <a:ext uri="{FF2B5EF4-FFF2-40B4-BE49-F238E27FC236}">
+                <a16:creationId xmlns:a16="http://schemas.microsoft.com/office/drawing/2014/main" id="{BDDB3E9C-31C2-AD3A-3D41-03AD9B39A2A2}"/>
+              </a:ext>
+            </a:extLst>
+          </p:cNvPr>
+          <p:cNvSpPr txBox="1"/>
+          <p:nvPr/>
+        </p:nvSpPr>
+        <p:spPr>
+          <a:xfrm>
+            <a:off x="6771945" y="4803707"/>
+            <a:ext cx="1933076" cy="646331"/>
+          </a:xfrm>
+          <a:prstGeom prst="rect">
+            <a:avLst/>
+          </a:prstGeom>
+          <a:solidFill>
+            <a:srgbClr val="FFF7ED"/>
+          </a:solidFill>
+          <a:ln w="28575">
+            <a:solidFill>
+              <a:srgbClr val="FED7AA"/>
+            </a:solidFill>
+          </a:ln>
+        </p:spPr>
+        <p:txBody>
+          <a:bodyPr wrap="square" rtlCol="0">
+            <a:spAutoFit/>
+          </a:bodyPr>
+          <a:lstStyle/>
+          <a:p>
+            <a:pPr algn="ctr"/>
+            <a:r>
+              <a:rPr lang="es-ES" dirty="0"/>
+              <a:t>Cajón monedas</a:t>
+            </a:r>
+          </a:p>
+        </p:txBody>
+      </p:sp>
+      <p:cxnSp>
+        <p:nvCxnSpPr>
+          <p:cNvPr id="21" name="Conector: angular 20">
+            <a:extLst>
+              <a:ext uri="{FF2B5EF4-FFF2-40B4-BE49-F238E27FC236}">
+                <a16:creationId xmlns:a16="http://schemas.microsoft.com/office/drawing/2014/main" id="{A5472820-A747-CA39-8791-4695B7AA21A5}"/>
+              </a:ext>
+            </a:extLst>
+          </p:cNvPr>
+          <p:cNvCxnSpPr>
+            <a:cxnSpLocks/>
+          </p:cNvCxnSpPr>
+          <p:nvPr/>
+        </p:nvCxnSpPr>
+        <p:spPr>
+          <a:xfrm rot="5400000">
+            <a:off x="4914339" y="3622717"/>
+            <a:ext cx="732197" cy="1629783"/>
+          </a:xfrm>
+          <a:prstGeom prst="bentConnector3">
+            <a:avLst>
+              <a:gd name="adj1" fmla="val 50000"/>
+            </a:avLst>
+          </a:prstGeom>
+          <a:ln>
+            <a:solidFill>
+              <a:srgbClr val="78716C"/>
+            </a:solidFill>
+          </a:ln>
+        </p:spPr>
+        <p:style>
+          <a:lnRef idx="1">
+            <a:schemeClr val="accent1"/>
+          </a:lnRef>
+          <a:fillRef idx="0">
+            <a:schemeClr val="accent1"/>
+          </a:fillRef>
+          <a:effectRef idx="0">
+            <a:schemeClr val="accent1"/>
+          </a:effectRef>
+          <a:fontRef idx="minor">
+            <a:schemeClr val="tx1"/>
+          </a:fontRef>
+        </p:style>
+      </p:cxnSp>
+      <p:cxnSp>
+        <p:nvCxnSpPr>
+          <p:cNvPr id="27" name="Conector: angular 26">
+            <a:extLst>
+              <a:ext uri="{FF2B5EF4-FFF2-40B4-BE49-F238E27FC236}">
+                <a16:creationId xmlns:a16="http://schemas.microsoft.com/office/drawing/2014/main" id="{DCC98548-E54A-CA79-4680-A89BCCC381E7}"/>
+              </a:ext>
+            </a:extLst>
+          </p:cNvPr>
+          <p:cNvCxnSpPr>
+            <a:stCxn id="19" idx="0"/>
+            <a:endCxn id="14" idx="2"/>
+          </p:cNvCxnSpPr>
+          <p:nvPr/>
+        </p:nvCxnSpPr>
+        <p:spPr>
+          <a:xfrm rot="16200000" flipV="1">
+            <a:off x="6551143" y="3616367"/>
+            <a:ext cx="732196" cy="1642484"/>
+          </a:xfrm>
+          <a:prstGeom prst="bentConnector3">
+            <a:avLst/>
+          </a:prstGeom>
+          <a:ln>
+            <a:solidFill>
+              <a:srgbClr val="78716C"/>
+            </a:solidFill>
+          </a:ln>
+        </p:spPr>
+        <p:style>
+          <a:lnRef idx="1">
+            <a:schemeClr val="accent1"/>
+          </a:lnRef>
+          <a:fillRef idx="0">
+            <a:schemeClr val="accent1"/>
+          </a:fillRef>
+          <a:effectRef idx="0">
+            <a:schemeClr val="accent1"/>
+          </a:effectRef>
+          <a:fontRef idx="minor">
+            <a:schemeClr val="tx1"/>
+          </a:fontRef>
+        </p:style>
+      </p:cxnSp>
+    </p:spTree>
+    <p:extLst>
+      <p:ext uri="{BB962C8B-B14F-4D97-AF65-F5344CB8AC3E}">
+        <p14:creationId xmlns:p14="http://schemas.microsoft.com/office/powerpoint/2010/main" val="2781848193"/>
+      </p:ext>
+    </p:extLst>
+  </p:cSld>
+  <p:clrMapOvr>
+    <a:masterClrMapping/>
+  </p:clrMapOvr>
+</p:sld>
+</file>
+
+<file path=ppt/slides/slide6.xml><?xml version="1.0" encoding="utf-8"?>
+<p:sld xmlns:a="http://schemas.openxmlformats.org/drawingml/2006/main" xmlns:r="http://schemas.openxmlformats.org/officeDocument/2006/relationships" xmlns:p="http://schemas.openxmlformats.org/presentationml/2006/main">
+  <p:cSld>
+    <p:spTree>
+      <p:nvGrpSpPr>
+        <p:cNvPr id="1" name=""/>
+        <p:cNvGrpSpPr/>
+        <p:nvPr/>
+      </p:nvGrpSpPr>
+      <p:grpSpPr>
+        <a:xfrm>
+          <a:off x="0" y="0"/>
+          <a:ext cx="0" cy="0"/>
+          <a:chOff x="0" y="0"/>
+          <a:chExt cx="0" cy="0"/>
+        </a:xfrm>
+      </p:grpSpPr>
+      <p:sp>
+        <p:nvSpPr>
+          <p:cNvPr id="2" name="Título 1">
+            <a:extLst>
+              <a:ext uri="{FF2B5EF4-FFF2-40B4-BE49-F238E27FC236}">
+                <a16:creationId xmlns:a16="http://schemas.microsoft.com/office/drawing/2014/main" id="{4FA197C1-3472-9C6C-C344-40D067C4613D}"/>
+              </a:ext>
+            </a:extLst>
+          </p:cNvPr>
+          <p:cNvSpPr>
+            <a:spLocks noGrp="1"/>
+          </p:cNvSpPr>
+          <p:nvPr>
+            <p:ph type="title"/>
+          </p:nvPr>
+        </p:nvSpPr>
+        <p:spPr/>
+        <p:txBody>
+          <a:bodyPr/>
+          <a:lstStyle/>
+          <a:p>
+            <a:r>
+              <a:rPr lang="es-ES" dirty="0"/>
+              <a:t>Funcionalidades clave</a:t>
+            </a:r>
+          </a:p>
+        </p:txBody>
+      </p:sp>
+      <p:sp>
+        <p:nvSpPr>
+          <p:cNvPr id="4" name="CuadroTexto 3">
+            <a:extLst>
+              <a:ext uri="{FF2B5EF4-FFF2-40B4-BE49-F238E27FC236}">
+                <a16:creationId xmlns:a16="http://schemas.microsoft.com/office/drawing/2014/main" id="{B65C9287-6E23-BEB9-B240-386087F72A7E}"/>
+              </a:ext>
+            </a:extLst>
+          </p:cNvPr>
+          <p:cNvSpPr txBox="1"/>
+          <p:nvPr/>
+        </p:nvSpPr>
+        <p:spPr>
+          <a:xfrm>
+            <a:off x="802640" y="1505152"/>
+            <a:ext cx="3251200" cy="2031325"/>
+          </a:xfrm>
+          <a:prstGeom prst="rect">
+            <a:avLst/>
+          </a:prstGeom>
+          <a:solidFill>
+            <a:srgbClr val="EFF6FF"/>
+          </a:solidFill>
+        </p:spPr>
+        <p:txBody>
+          <a:bodyPr wrap="square" rtlCol="0">
+            <a:spAutoFit/>
+          </a:bodyPr>
+          <a:lstStyle/>
+          <a:p>
+            <a:pPr algn="ctr"/>
+            <a:r>
+              <a:rPr lang="es-ES" b="1" dirty="0"/>
+              <a:t>TPV</a:t>
+            </a:r>
+          </a:p>
+          <a:p>
+            <a:endParaRPr lang="es-ES" dirty="0"/>
+          </a:p>
+          <a:p>
+            <a:pPr marL="285750" indent="-285750">
+              <a:buFont typeface="Wingdings" panose="05000000000000000000" pitchFamily="2" charset="2"/>
+              <a:buChar char="q"/>
+            </a:pPr>
+            <a:r>
+              <a:rPr lang="es-ES" dirty="0"/>
+              <a:t>Crear tickets</a:t>
+            </a:r>
+          </a:p>
+          <a:p>
+            <a:pPr marL="285750" indent="-285750">
+              <a:buFont typeface="Wingdings" panose="05000000000000000000" pitchFamily="2" charset="2"/>
+              <a:buChar char="q"/>
+            </a:pPr>
+            <a:r>
+              <a:rPr lang="es-ES" dirty="0"/>
+              <a:t>Cobrar tickets</a:t>
+            </a:r>
+          </a:p>
+          <a:p>
+            <a:pPr marL="285750" indent="-285750">
+              <a:buFont typeface="Wingdings" panose="05000000000000000000" pitchFamily="2" charset="2"/>
+              <a:buChar char="q"/>
+            </a:pPr>
+            <a:r>
+              <a:rPr lang="es-ES" dirty="0"/>
+              <a:t>Imprimir tickets</a:t>
+            </a:r>
+          </a:p>
+          <a:p>
+            <a:pPr marL="285750" indent="-285750">
+              <a:buFont typeface="Wingdings" panose="05000000000000000000" pitchFamily="2" charset="2"/>
+              <a:buChar char="q"/>
+            </a:pPr>
+            <a:r>
+              <a:rPr lang="es-ES" dirty="0"/>
+              <a:t>Email al cliente con ticket</a:t>
+            </a:r>
+          </a:p>
+        </p:txBody>
+      </p:sp>
+      <p:sp>
+        <p:nvSpPr>
+          <p:cNvPr id="5" name="CuadroTexto 4">
+            <a:extLst>
+              <a:ext uri="{FF2B5EF4-FFF2-40B4-BE49-F238E27FC236}">
+                <a16:creationId xmlns:a16="http://schemas.microsoft.com/office/drawing/2014/main" id="{A75AD68C-4B70-5CDE-7B27-4DCD68727347}"/>
+              </a:ext>
+            </a:extLst>
+          </p:cNvPr>
+          <p:cNvSpPr txBox="1"/>
+          <p:nvPr/>
+        </p:nvSpPr>
+        <p:spPr>
+          <a:xfrm>
+            <a:off x="4470400" y="1505151"/>
+            <a:ext cx="3251200" cy="2031325"/>
+          </a:xfrm>
+          <a:prstGeom prst="rect">
+            <a:avLst/>
+          </a:prstGeom>
+          <a:solidFill>
+            <a:srgbClr val="F0FDF4"/>
+          </a:solidFill>
+        </p:spPr>
+        <p:txBody>
+          <a:bodyPr wrap="square" rtlCol="0">
+            <a:spAutoFit/>
+          </a:bodyPr>
+          <a:lstStyle/>
+          <a:p>
+            <a:pPr algn="ctr"/>
+            <a:r>
+              <a:rPr lang="es-ES" b="1" dirty="0"/>
+              <a:t>DASHBOARD</a:t>
+            </a:r>
+          </a:p>
+          <a:p>
+            <a:endParaRPr lang="es-ES" dirty="0"/>
+          </a:p>
+          <a:p>
+            <a:pPr marL="285750" indent="-285750">
+              <a:buFont typeface="Wingdings" panose="05000000000000000000" pitchFamily="2" charset="2"/>
+              <a:buChar char="q"/>
+            </a:pPr>
+            <a:r>
+              <a:rPr lang="es-ES" dirty="0"/>
+              <a:t>Estadísticas de venta</a:t>
+            </a:r>
+          </a:p>
+          <a:p>
+            <a:pPr marL="285750" indent="-285750">
+              <a:buFont typeface="Wingdings" panose="05000000000000000000" pitchFamily="2" charset="2"/>
+              <a:buChar char="q"/>
+            </a:pPr>
+            <a:r>
+              <a:rPr lang="es-ES" dirty="0"/>
+              <a:t>Gráficos por meses</a:t>
+            </a:r>
+          </a:p>
+          <a:p>
+            <a:pPr marL="285750" indent="-285750">
+              <a:buFont typeface="Wingdings" panose="05000000000000000000" pitchFamily="2" charset="2"/>
+              <a:buChar char="q"/>
+            </a:pPr>
+            <a:r>
+              <a:rPr lang="es-ES" dirty="0"/>
+              <a:t>Informes fin día</a:t>
+            </a:r>
+          </a:p>
+          <a:p>
+            <a:pPr marL="285750" indent="-285750">
+              <a:buFont typeface="Wingdings" panose="05000000000000000000" pitchFamily="2" charset="2"/>
+              <a:buChar char="q"/>
+            </a:pPr>
+            <a:r>
+              <a:rPr lang="es-ES" dirty="0"/>
+              <a:t>Mantenimiento artículos</a:t>
+            </a:r>
+          </a:p>
+          <a:p>
+            <a:endParaRPr lang="es-ES" dirty="0"/>
+          </a:p>
+        </p:txBody>
+      </p:sp>
+      <p:sp>
+        <p:nvSpPr>
+          <p:cNvPr id="6" name="CuadroTexto 5">
+            <a:extLst>
+              <a:ext uri="{FF2B5EF4-FFF2-40B4-BE49-F238E27FC236}">
+                <a16:creationId xmlns:a16="http://schemas.microsoft.com/office/drawing/2014/main" id="{F9DDB19E-DB00-6585-C474-687F635A49F5}"/>
+              </a:ext>
+            </a:extLst>
+          </p:cNvPr>
+          <p:cNvSpPr txBox="1"/>
+          <p:nvPr/>
+        </p:nvSpPr>
+        <p:spPr>
+          <a:xfrm>
+            <a:off x="8138160" y="1505151"/>
+            <a:ext cx="3251200" cy="2031325"/>
+          </a:xfrm>
+          <a:prstGeom prst="rect">
+            <a:avLst/>
+          </a:prstGeom>
+          <a:solidFill>
+            <a:srgbClr val="FAF5FF"/>
+          </a:solidFill>
+        </p:spPr>
+        <p:txBody>
+          <a:bodyPr wrap="square" rtlCol="0">
+            <a:spAutoFit/>
+          </a:bodyPr>
+          <a:lstStyle/>
+          <a:p>
+            <a:pPr algn="ctr"/>
+            <a:r>
+              <a:rPr lang="es-ES" b="1" dirty="0"/>
+              <a:t>ROLES</a:t>
+            </a:r>
+          </a:p>
+          <a:p>
+            <a:pPr marL="285750" indent="-285750">
+              <a:buFont typeface="Wingdings" panose="05000000000000000000" pitchFamily="2" charset="2"/>
+              <a:buChar char="q"/>
+            </a:pPr>
+            <a:endParaRPr lang="es-ES" dirty="0"/>
+          </a:p>
+          <a:p>
+            <a:pPr marL="285750" indent="-285750">
+              <a:buFont typeface="Wingdings" panose="05000000000000000000" pitchFamily="2" charset="2"/>
+              <a:buChar char="q"/>
+            </a:pPr>
+            <a:r>
+              <a:rPr lang="es-ES" dirty="0" err="1"/>
+              <a:t>Admin</a:t>
+            </a:r>
+            <a:r>
+              <a:rPr lang="es-ES" dirty="0"/>
+              <a:t> vs Usuario</a:t>
+            </a:r>
+          </a:p>
+          <a:p>
+            <a:pPr marL="285750" indent="-285750">
+              <a:buFont typeface="Wingdings" panose="05000000000000000000" pitchFamily="2" charset="2"/>
+              <a:buChar char="q"/>
+            </a:pPr>
+            <a:r>
+              <a:rPr lang="es-ES" dirty="0"/>
+              <a:t>Rutas propias para cada tipo de usuario</a:t>
+            </a:r>
+          </a:p>
+          <a:p>
+            <a:endParaRPr lang="es-ES" dirty="0"/>
+          </a:p>
+          <a:p>
+            <a:endParaRPr lang="es-ES" dirty="0"/>
+          </a:p>
+        </p:txBody>
+      </p:sp>
+      <p:pic>
+        <p:nvPicPr>
+          <p:cNvPr id="8" name="Imagen 7">
+            <a:extLst>
+              <a:ext uri="{FF2B5EF4-FFF2-40B4-BE49-F238E27FC236}">
+                <a16:creationId xmlns:a16="http://schemas.microsoft.com/office/drawing/2014/main" id="{0FC34E57-A3AD-29B2-3A56-C70C7583926B}"/>
+              </a:ext>
+            </a:extLst>
+          </p:cNvPr>
+          <p:cNvPicPr>
+            <a:picLocks noChangeAspect="1"/>
+          </p:cNvPicPr>
+          <p:nvPr/>
+        </p:nvPicPr>
+        <p:blipFill>
+          <a:blip r:embed="rId2"/>
+          <a:stretch>
+            <a:fillRect/>
+          </a:stretch>
+        </p:blipFill>
+        <p:spPr>
+          <a:xfrm>
+            <a:off x="3068320" y="3677920"/>
+            <a:ext cx="6191888" cy="2952359"/>
+          </a:xfrm>
+          <a:prstGeom prst="rect">
+            <a:avLst/>
+          </a:prstGeom>
+        </p:spPr>
+      </p:pic>
+    </p:spTree>
+    <p:extLst>
+      <p:ext uri="{BB962C8B-B14F-4D97-AF65-F5344CB8AC3E}">
+        <p14:creationId xmlns:p14="http://schemas.microsoft.com/office/powerpoint/2010/main" val="3908740804"/>
+      </p:ext>
+    </p:extLst>
+  </p:cSld>
+  <p:clrMapOvr>
+    <a:masterClrMapping/>
+  </p:clrMapOvr>
+</p:sld>
+</file>
+
+<file path=ppt/slides/slide7.xml><?xml version="1.0" encoding="utf-8"?>
+<p:sld xmlns:a="http://schemas.openxmlformats.org/drawingml/2006/main" xmlns:r="http://schemas.openxmlformats.org/officeDocument/2006/relationships" xmlns:p="http://schemas.openxmlformats.org/presentationml/2006/main">
+  <p:cSld>
+    <p:spTree>
+      <p:nvGrpSpPr>
+        <p:cNvPr id="1" name=""/>
+        <p:cNvGrpSpPr/>
+        <p:nvPr/>
+      </p:nvGrpSpPr>
+      <p:grpSpPr>
+        <a:xfrm>
+          <a:off x="0" y="0"/>
+          <a:ext cx="0" cy="0"/>
+          <a:chOff x="0" y="0"/>
+          <a:chExt cx="0" cy="0"/>
+        </a:xfrm>
+      </p:grpSpPr>
+      <p:sp>
+        <p:nvSpPr>
+          <p:cNvPr id="2" name="Título 1">
+            <a:extLst>
+              <a:ext uri="{FF2B5EF4-FFF2-40B4-BE49-F238E27FC236}">
+                <a16:creationId xmlns:a16="http://schemas.microsoft.com/office/drawing/2014/main" id="{FD66D483-EF53-62F0-A07B-08C1678B9FBE}"/>
+              </a:ext>
+            </a:extLst>
+          </p:cNvPr>
+          <p:cNvSpPr>
+            <a:spLocks noGrp="1"/>
+          </p:cNvSpPr>
+          <p:nvPr>
+            <p:ph type="title"/>
+          </p:nvPr>
+        </p:nvSpPr>
+        <p:spPr/>
+        <p:txBody>
+          <a:bodyPr/>
+          <a:lstStyle/>
+          <a:p>
+            <a:r>
+              <a:rPr lang="es-ES" dirty="0"/>
+              <a:t>Retos técnicos</a:t>
+            </a:r>
+          </a:p>
+        </p:txBody>
+      </p:sp>
+      <p:sp>
+        <p:nvSpPr>
+          <p:cNvPr id="5" name="CuadroTexto 4">
+            <a:extLst>
+              <a:ext uri="{FF2B5EF4-FFF2-40B4-BE49-F238E27FC236}">
+                <a16:creationId xmlns:a16="http://schemas.microsoft.com/office/drawing/2014/main" id="{0CCEBB0F-6FF1-8D6E-A5BB-884EE2F462EB}"/>
+              </a:ext>
+            </a:extLst>
+          </p:cNvPr>
+          <p:cNvSpPr txBox="1"/>
+          <p:nvPr/>
+        </p:nvSpPr>
+        <p:spPr>
+          <a:xfrm>
+            <a:off x="2184400" y="1656080"/>
+            <a:ext cx="8666480" cy="1200329"/>
+          </a:xfrm>
+          <a:prstGeom prst="rect">
+            <a:avLst/>
+          </a:prstGeom>
+          <a:solidFill>
+            <a:srgbClr val="F9FAFB"/>
+          </a:solidFill>
+        </p:spPr>
+        <p:txBody>
+          <a:bodyPr wrap="square" rtlCol="0">
+            <a:spAutoFit/>
+          </a:bodyPr>
+          <a:lstStyle/>
+          <a:p>
+            <a:r>
+              <a:rPr lang="es-ES" dirty="0"/>
+              <a:t>Hardware local desde una app en la nube </a:t>
+            </a:r>
+          </a:p>
+          <a:p>
+            <a:r>
+              <a:rPr lang="es-ES" b="1" dirty="0">
+                <a:solidFill>
+                  <a:srgbClr val="EF4444"/>
+                </a:solidFill>
+              </a:rPr>
+              <a:t>Problema</a:t>
+            </a:r>
+            <a:r>
+              <a:rPr lang="es-ES" dirty="0"/>
+              <a:t>: la impresora no es accesible desde </a:t>
+            </a:r>
+            <a:r>
+              <a:rPr lang="es-ES" dirty="0" err="1"/>
+              <a:t>Vercel</a:t>
+            </a:r>
+            <a:r>
+              <a:rPr lang="es-ES" dirty="0"/>
+              <a:t> directamente.                 </a:t>
+            </a:r>
+          </a:p>
+          <a:p>
+            <a:r>
+              <a:rPr lang="es-ES" b="1" dirty="0">
+                <a:solidFill>
+                  <a:srgbClr val="16A34A"/>
+                </a:solidFill>
+              </a:rPr>
+              <a:t>Solución</a:t>
+            </a:r>
+            <a:r>
+              <a:rPr lang="es-ES" dirty="0"/>
+              <a:t>: </a:t>
+            </a:r>
+            <a:r>
+              <a:rPr lang="es-ES" dirty="0" err="1"/>
+              <a:t>Printer</a:t>
+            </a:r>
+            <a:r>
+              <a:rPr lang="es-ES" dirty="0"/>
+              <a:t> Server en Node.js local que recibe peticiones HTTP desde Next.js </a:t>
+            </a:r>
+          </a:p>
+        </p:txBody>
+      </p:sp>
+      <p:cxnSp>
+        <p:nvCxnSpPr>
+          <p:cNvPr id="9" name="Conector recto 8">
+            <a:extLst>
+              <a:ext uri="{FF2B5EF4-FFF2-40B4-BE49-F238E27FC236}">
+                <a16:creationId xmlns:a16="http://schemas.microsoft.com/office/drawing/2014/main" id="{B3C49DC6-83F1-678B-FAC0-5283FE423941}"/>
+              </a:ext>
+            </a:extLst>
+          </p:cNvPr>
+          <p:cNvCxnSpPr/>
+          <p:nvPr/>
+        </p:nvCxnSpPr>
+        <p:spPr>
+          <a:xfrm>
+            <a:off x="2184400" y="1656080"/>
+            <a:ext cx="0" cy="1200329"/>
+          </a:xfrm>
+          <a:prstGeom prst="line">
+            <a:avLst/>
+          </a:prstGeom>
+          <a:ln w="38100">
+            <a:solidFill>
+              <a:srgbClr val="F97316"/>
+            </a:solidFill>
+          </a:ln>
+        </p:spPr>
+        <p:style>
+          <a:lnRef idx="1">
+            <a:schemeClr val="accent1"/>
+          </a:lnRef>
+          <a:fillRef idx="0">
+            <a:schemeClr val="accent1"/>
+          </a:fillRef>
+          <a:effectRef idx="0">
+            <a:schemeClr val="accent1"/>
+          </a:effectRef>
+          <a:fontRef idx="minor">
+            <a:schemeClr val="tx1"/>
+          </a:fontRef>
+        </p:style>
+      </p:cxnSp>
+      <p:sp>
+        <p:nvSpPr>
+          <p:cNvPr id="10" name="CuadroTexto 9">
+            <a:extLst>
+              <a:ext uri="{FF2B5EF4-FFF2-40B4-BE49-F238E27FC236}">
+                <a16:creationId xmlns:a16="http://schemas.microsoft.com/office/drawing/2014/main" id="{4B5FD2F7-EB2B-AFB5-766B-FEC7E83BD74E}"/>
+              </a:ext>
+            </a:extLst>
+          </p:cNvPr>
+          <p:cNvSpPr txBox="1"/>
+          <p:nvPr/>
+        </p:nvSpPr>
+        <p:spPr>
+          <a:xfrm>
+            <a:off x="2184400" y="3108960"/>
+            <a:ext cx="8666480" cy="1200329"/>
+          </a:xfrm>
+          <a:prstGeom prst="rect">
+            <a:avLst/>
+          </a:prstGeom>
+          <a:solidFill>
+            <a:srgbClr val="F9FAFB"/>
+          </a:solidFill>
+        </p:spPr>
+        <p:txBody>
+          <a:bodyPr wrap="square" rtlCol="0">
+            <a:spAutoFit/>
+          </a:bodyPr>
+          <a:lstStyle/>
+          <a:p>
+            <a:r>
+              <a:rPr lang="es-ES" dirty="0"/>
+              <a:t>Generación y envío de PDF al vuelo</a:t>
+            </a:r>
+          </a:p>
+          <a:p>
+            <a:r>
+              <a:rPr lang="es-ES" b="1" dirty="0">
+                <a:solidFill>
+                  <a:srgbClr val="EF4444"/>
+                </a:solidFill>
+              </a:rPr>
+              <a:t>Problema</a:t>
+            </a:r>
+            <a:r>
+              <a:rPr lang="es-ES" dirty="0"/>
+              <a:t>: generar un PDF del ticket y enviarlo por email en el momento del cobro.</a:t>
+            </a:r>
+          </a:p>
+          <a:p>
+            <a:r>
+              <a:rPr lang="es-ES" b="1" dirty="0">
+                <a:solidFill>
+                  <a:srgbClr val="16A34A"/>
+                </a:solidFill>
+              </a:rPr>
+              <a:t>Solución</a:t>
+            </a:r>
+            <a:r>
+              <a:rPr lang="es-ES" dirty="0"/>
+              <a:t>: React-PDF + </a:t>
+            </a:r>
+            <a:r>
+              <a:rPr lang="es-ES" dirty="0" err="1"/>
+              <a:t>Nodemailer</a:t>
+            </a:r>
+            <a:r>
+              <a:rPr lang="es-ES" dirty="0"/>
+              <a:t> </a:t>
+            </a:r>
+          </a:p>
+        </p:txBody>
+      </p:sp>
+      <p:cxnSp>
+        <p:nvCxnSpPr>
+          <p:cNvPr id="11" name="Conector recto 10">
+            <a:extLst>
+              <a:ext uri="{FF2B5EF4-FFF2-40B4-BE49-F238E27FC236}">
+                <a16:creationId xmlns:a16="http://schemas.microsoft.com/office/drawing/2014/main" id="{2BBEDDAA-7BD8-8250-3900-0C4194D85D21}"/>
+              </a:ext>
+            </a:extLst>
+          </p:cNvPr>
+          <p:cNvCxnSpPr/>
+          <p:nvPr/>
+        </p:nvCxnSpPr>
+        <p:spPr>
+          <a:xfrm>
+            <a:off x="2184400" y="3108960"/>
+            <a:ext cx="0" cy="1200329"/>
+          </a:xfrm>
+          <a:prstGeom prst="line">
+            <a:avLst/>
+          </a:prstGeom>
+          <a:ln w="38100">
+            <a:solidFill>
+              <a:srgbClr val="3B82F6"/>
+            </a:solidFill>
+          </a:ln>
+        </p:spPr>
+        <p:style>
+          <a:lnRef idx="1">
+            <a:schemeClr val="accent1"/>
+          </a:lnRef>
+          <a:fillRef idx="0">
+            <a:schemeClr val="accent1"/>
+          </a:fillRef>
+          <a:effectRef idx="0">
+            <a:schemeClr val="accent1"/>
+          </a:effectRef>
+          <a:fontRef idx="minor">
+            <a:schemeClr val="tx1"/>
+          </a:fontRef>
+        </p:style>
+      </p:cxnSp>
+      <p:sp>
+        <p:nvSpPr>
+          <p:cNvPr id="12" name="CuadroTexto 11">
+            <a:extLst>
+              <a:ext uri="{FF2B5EF4-FFF2-40B4-BE49-F238E27FC236}">
+                <a16:creationId xmlns:a16="http://schemas.microsoft.com/office/drawing/2014/main" id="{D544CA0A-0CCA-4B97-AAC7-2008B7D95B65}"/>
+              </a:ext>
+            </a:extLst>
+          </p:cNvPr>
+          <p:cNvSpPr txBox="1"/>
+          <p:nvPr/>
+        </p:nvSpPr>
+        <p:spPr>
+          <a:xfrm>
+            <a:off x="2184400" y="4561840"/>
+            <a:ext cx="8666480" cy="923330"/>
+          </a:xfrm>
+          <a:prstGeom prst="rect">
+            <a:avLst/>
+          </a:prstGeom>
+          <a:solidFill>
+            <a:srgbClr val="F9FAFB"/>
+          </a:solidFill>
+        </p:spPr>
+        <p:txBody>
+          <a:bodyPr wrap="square" rtlCol="0">
+            <a:spAutoFit/>
+          </a:bodyPr>
+          <a:lstStyle/>
+          <a:p>
+            <a:r>
+              <a:rPr lang="es-ES" dirty="0"/>
+              <a:t>Autenticación y control de acceso por rol</a:t>
+            </a:r>
+          </a:p>
+          <a:p>
+            <a:r>
+              <a:rPr lang="es-ES" b="1" dirty="0">
+                <a:solidFill>
+                  <a:srgbClr val="EF4444"/>
+                </a:solidFill>
+              </a:rPr>
+              <a:t>Problema</a:t>
+            </a:r>
+            <a:r>
+              <a:rPr lang="es-ES" dirty="0"/>
+              <a:t>:  cada rol debe ver solo su interfaz y acceder solo a sus rutas.</a:t>
+            </a:r>
+          </a:p>
+          <a:p>
+            <a:r>
+              <a:rPr lang="es-ES" b="1" dirty="0">
+                <a:solidFill>
+                  <a:srgbClr val="16A34A"/>
+                </a:solidFill>
+              </a:rPr>
+              <a:t>Solución</a:t>
+            </a:r>
+            <a:r>
+              <a:rPr lang="es-ES" dirty="0"/>
+              <a:t>: </a:t>
+            </a:r>
+            <a:r>
+              <a:rPr lang="en-US" dirty="0" err="1"/>
+              <a:t>NextAuth</a:t>
+            </a:r>
+            <a:r>
+              <a:rPr lang="en-US" dirty="0"/>
+              <a:t> con middleware de </a:t>
+            </a:r>
+            <a:r>
+              <a:rPr lang="en-US" dirty="0" err="1"/>
+              <a:t>rutas</a:t>
+            </a:r>
+            <a:endParaRPr lang="es-ES" dirty="0"/>
+          </a:p>
+        </p:txBody>
+      </p:sp>
+      <p:cxnSp>
+        <p:nvCxnSpPr>
+          <p:cNvPr id="13" name="Conector recto 12">
+            <a:extLst>
+              <a:ext uri="{FF2B5EF4-FFF2-40B4-BE49-F238E27FC236}">
+                <a16:creationId xmlns:a16="http://schemas.microsoft.com/office/drawing/2014/main" id="{184211D8-21F1-5CCD-2B8C-388682969171}"/>
+              </a:ext>
+            </a:extLst>
+          </p:cNvPr>
+          <p:cNvCxnSpPr>
+            <a:cxnSpLocks/>
+          </p:cNvCxnSpPr>
+          <p:nvPr/>
+        </p:nvCxnSpPr>
+        <p:spPr>
+          <a:xfrm>
+            <a:off x="2194560" y="4561840"/>
+            <a:ext cx="0" cy="923330"/>
+          </a:xfrm>
+          <a:prstGeom prst="line">
+            <a:avLst/>
+          </a:prstGeom>
+          <a:ln w="38100">
+            <a:solidFill>
+              <a:srgbClr val="22C55E"/>
+            </a:solidFill>
+          </a:ln>
+        </p:spPr>
+        <p:style>
+          <a:lnRef idx="1">
+            <a:schemeClr val="accent1"/>
+          </a:lnRef>
+          <a:fillRef idx="0">
+            <a:schemeClr val="accent1"/>
+          </a:fillRef>
+          <a:effectRef idx="0">
+            <a:schemeClr val="accent1"/>
+          </a:effectRef>
+          <a:fontRef idx="minor">
+            <a:schemeClr val="tx1"/>
+          </a:fontRef>
+        </p:style>
+      </p:cxnSp>
+    </p:spTree>
+    <p:extLst>
+      <p:ext uri="{BB962C8B-B14F-4D97-AF65-F5344CB8AC3E}">
+        <p14:creationId xmlns:p14="http://schemas.microsoft.com/office/powerpoint/2010/main" val="4057779969"/>
+      </p:ext>
+    </p:extLst>
+  </p:cSld>
+  <p:clrMapOvr>
+    <a:masterClrMapping/>
+  </p:clrMapOvr>
+</p:sld>
+</file>
+
 <file path=ppt/theme/theme1.xml><?xml version="1.0" encoding="utf-8"?>
 <a:theme xmlns:a="http://schemas.openxmlformats.org/drawingml/2006/main" name="Espiral">
   <a:themeElements>

</xml_diff>

<commit_message>
feat: finish project presentation
</commit_message>
<xml_diff>
--- a/documentacion proyecto/Presentacion_proyecto.pptx
+++ b/documentacion proyecto/Presentacion_proyecto.pptx
@@ -12,6 +12,8 @@
     <p:sldId id="260" r:id="rId6"/>
     <p:sldId id="261" r:id="rId7"/>
     <p:sldId id="262" r:id="rId8"/>
+    <p:sldId id="263" r:id="rId9"/>
+    <p:sldId id="264" r:id="rId10"/>
   </p:sldIdLst>
   <p:sldSz cx="12192000" cy="6858000"/>
   <p:notesSz cx="6858000" cy="9144000"/>
@@ -306,7 +308,7 @@
           <a:p>
             <a:fld id="{7DA38F49-B3E2-4BF0-BEC7-C30D34ABBB8D}" type="datetime1">
               <a:rPr lang="en-US" smtClean="0"/>
-              <a:t>5/12/2026</a:t>
+              <a:t>5/14/2026</a:t>
             </a:fld>
             <a:endParaRPr lang="en-US"/>
           </a:p>
@@ -652,7 +654,7 @@
           <a:p>
             <a:fld id="{7DA38F49-B3E2-4BF0-BEC7-C30D34ABBB8D}" type="datetime1">
               <a:rPr lang="en-US" smtClean="0"/>
-              <a:t>5/12/2026</a:t>
+              <a:t>5/14/2026</a:t>
             </a:fld>
             <a:endParaRPr lang="en-US"/>
           </a:p>
@@ -1054,7 +1056,7 @@
           <a:p>
             <a:fld id="{7DA38F49-B3E2-4BF0-BEC7-C30D34ABBB8D}" type="datetime1">
               <a:rPr lang="en-US" smtClean="0"/>
-              <a:t>5/12/2026</a:t>
+              <a:t>5/14/2026</a:t>
             </a:fld>
             <a:endParaRPr lang="en-US"/>
           </a:p>
@@ -1391,7 +1393,7 @@
           <a:p>
             <a:fld id="{7DA38F49-B3E2-4BF0-BEC7-C30D34ABBB8D}" type="datetime1">
               <a:rPr lang="en-US" smtClean="0"/>
-              <a:t>5/12/2026</a:t>
+              <a:t>5/14/2026</a:t>
             </a:fld>
             <a:endParaRPr lang="en-US"/>
           </a:p>
@@ -1712,7 +1714,7 @@
           <a:p>
             <a:fld id="{7DA38F49-B3E2-4BF0-BEC7-C30D34ABBB8D}" type="datetime1">
               <a:rPr lang="en-US" smtClean="0"/>
-              <a:t>5/12/2026</a:t>
+              <a:t>5/14/2026</a:t>
             </a:fld>
             <a:endParaRPr lang="en-US"/>
           </a:p>
@@ -2109,7 +2111,7 @@
           <a:p>
             <a:fld id="{7DA38F49-B3E2-4BF0-BEC7-C30D34ABBB8D}" type="datetime1">
               <a:rPr lang="en-US" smtClean="0"/>
-              <a:t>5/12/2026</a:t>
+              <a:t>5/14/2026</a:t>
             </a:fld>
             <a:endParaRPr lang="en-US"/>
           </a:p>
@@ -2367,7 +2369,7 @@
           <a:p>
             <a:fld id="{7DA38F49-B3E2-4BF0-BEC7-C30D34ABBB8D}" type="datetime1">
               <a:rPr lang="en-US" smtClean="0"/>
-              <a:t>5/12/2026</a:t>
+              <a:t>5/14/2026</a:t>
             </a:fld>
             <a:endParaRPr lang="en-US"/>
           </a:p>
@@ -2630,7 +2632,7 @@
           <a:p>
             <a:fld id="{7DA38F49-B3E2-4BF0-BEC7-C30D34ABBB8D}" type="datetime1">
               <a:rPr lang="en-US" smtClean="0"/>
-              <a:t>5/12/2026</a:t>
+              <a:t>5/14/2026</a:t>
             </a:fld>
             <a:endParaRPr lang="en-US"/>
           </a:p>
@@ -2893,7 +2895,7 @@
           <a:p>
             <a:fld id="{7DA38F49-B3E2-4BF0-BEC7-C30D34ABBB8D}" type="datetime1">
               <a:rPr lang="en-US" smtClean="0"/>
-              <a:t>5/12/2026</a:t>
+              <a:t>5/14/2026</a:t>
             </a:fld>
             <a:endParaRPr lang="en-US"/>
           </a:p>
@@ -3223,7 +3225,7 @@
           <a:p>
             <a:fld id="{7DA38F49-B3E2-4BF0-BEC7-C30D34ABBB8D}" type="datetime1">
               <a:rPr lang="en-US" smtClean="0"/>
-              <a:t>5/12/2026</a:t>
+              <a:t>5/14/2026</a:t>
             </a:fld>
             <a:endParaRPr lang="en-US"/>
           </a:p>
@@ -3547,7 +3549,7 @@
           <a:p>
             <a:fld id="{7DA38F49-B3E2-4BF0-BEC7-C30D34ABBB8D}" type="datetime1">
               <a:rPr lang="en-US" smtClean="0"/>
-              <a:t>5/12/2026</a:t>
+              <a:t>5/14/2026</a:t>
             </a:fld>
             <a:endParaRPr lang="en-US"/>
           </a:p>
@@ -4005,7 +4007,7 @@
           <a:p>
             <a:fld id="{7DA38F49-B3E2-4BF0-BEC7-C30D34ABBB8D}" type="datetime1">
               <a:rPr lang="en-US" smtClean="0"/>
-              <a:t>5/12/2026</a:t>
+              <a:t>5/14/2026</a:t>
             </a:fld>
             <a:endParaRPr lang="en-US"/>
           </a:p>
@@ -4211,7 +4213,7 @@
           <a:p>
             <a:fld id="{7DA38F49-B3E2-4BF0-BEC7-C30D34ABBB8D}" type="datetime1">
               <a:rPr lang="en-US" smtClean="0"/>
-              <a:t>5/12/2026</a:t>
+              <a:t>5/14/2026</a:t>
             </a:fld>
             <a:endParaRPr lang="en-US"/>
           </a:p>
@@ -4389,7 +4391,7 @@
           <a:p>
             <a:fld id="{7DA38F49-B3E2-4BF0-BEC7-C30D34ABBB8D}" type="datetime1">
               <a:rPr lang="en-US" smtClean="0"/>
-              <a:t>5/12/2026</a:t>
+              <a:t>5/14/2026</a:t>
             </a:fld>
             <a:endParaRPr lang="en-US"/>
           </a:p>
@@ -4723,7 +4725,7 @@
           <a:p>
             <a:fld id="{7DA38F49-B3E2-4BF0-BEC7-C30D34ABBB8D}" type="datetime1">
               <a:rPr lang="en-US" smtClean="0"/>
-              <a:t>5/12/2026</a:t>
+              <a:t>5/14/2026</a:t>
             </a:fld>
             <a:endParaRPr lang="en-US"/>
           </a:p>
@@ -5069,7 +5071,7 @@
           <a:p>
             <a:fld id="{7DA38F49-B3E2-4BF0-BEC7-C30D34ABBB8D}" type="datetime1">
               <a:rPr lang="en-US" smtClean="0"/>
-              <a:t>5/12/2026</a:t>
+              <a:t>5/14/2026</a:t>
             </a:fld>
             <a:endParaRPr lang="en-US"/>
           </a:p>
@@ -7362,7 +7364,7 @@
           <a:p>
             <a:fld id="{7DA38F49-B3E2-4BF0-BEC7-C30D34ABBB8D}" type="datetime1">
               <a:rPr lang="en-US" smtClean="0"/>
-              <a:t>5/12/2026</a:t>
+              <a:t>5/14/2026</a:t>
             </a:fld>
             <a:endParaRPr lang="en-US"/>
           </a:p>
@@ -7918,9 +7920,14 @@
           <a:lstStyle/>
           <a:p>
             <a:r>
-              <a:rPr lang="es-ES" sz="5800"/>
-              <a:t>BsnessApp</a:t>
-            </a:r>
+              <a:rPr lang="es-ES" sz="5800" dirty="0" err="1"/>
+              <a:t>Bsness</a:t>
+            </a:r>
+            <a:r>
+              <a:rPr lang="es-ES" sz="5800" b="1" dirty="0" err="1"/>
+              <a:t>App</a:t>
+            </a:r>
+            <a:endParaRPr lang="es-ES" sz="5800" b="1" dirty="0"/>
           </a:p>
         </p:txBody>
       </p:sp>
@@ -7958,8 +7965,8 @@
               </a:lnSpc>
             </a:pPr>
             <a:r>
-              <a:rPr lang="es-ES"/>
-              <a:t>Fu jun fu lin</a:t>
+              <a:rPr lang="es-ES" dirty="0"/>
+              <a:t>FU JUN FU LIN</a:t>
             </a:r>
           </a:p>
           <a:p>
@@ -7969,8 +7976,8 @@
               </a:lnSpc>
             </a:pPr>
             <a:r>
-              <a:rPr lang="es-ES"/>
-              <a:t>2daw semipresencial 2025-26</a:t>
+              <a:rPr lang="es-ES" dirty="0"/>
+              <a:t>2DAW semipresencial 2025-26</a:t>
             </a:r>
           </a:p>
         </p:txBody>
@@ -8641,6 +8648,16 @@
 <file path=ppt/slides/slide3.xml><?xml version="1.0" encoding="utf-8"?>
 <p:sld xmlns:a="http://schemas.openxmlformats.org/drawingml/2006/main" xmlns:r="http://schemas.openxmlformats.org/officeDocument/2006/relationships" xmlns:p="http://schemas.openxmlformats.org/presentationml/2006/main">
   <p:cSld>
+    <p:bg>
+      <p:bgPr>
+        <a:solidFill>
+          <a:schemeClr val="accent1">
+            <a:alpha val="0"/>
+          </a:schemeClr>
+        </a:solidFill>
+        <a:effectLst/>
+      </p:bgPr>
+    </p:bg>
     <p:spTree>
       <p:nvGrpSpPr>
         <p:cNvPr id="1" name=""/>
@@ -8951,6 +8968,16 @@
 <file path=ppt/slides/slide4.xml><?xml version="1.0" encoding="utf-8"?>
 <p:sld xmlns:a="http://schemas.openxmlformats.org/drawingml/2006/main" xmlns:r="http://schemas.openxmlformats.org/officeDocument/2006/relationships" xmlns:p="http://schemas.openxmlformats.org/presentationml/2006/main">
   <p:cSld>
+    <p:bg>
+      <p:bgPr>
+        <a:solidFill>
+          <a:schemeClr val="accent1">
+            <a:alpha val="0"/>
+          </a:schemeClr>
+        </a:solidFill>
+        <a:effectLst/>
+      </p:bgPr>
+    </p:bg>
     <p:spTree>
       <p:nvGrpSpPr>
         <p:cNvPr id="1" name=""/>
@@ -9230,6 +9257,16 @@
 <file path=ppt/slides/slide5.xml><?xml version="1.0" encoding="utf-8"?>
 <p:sld xmlns:a="http://schemas.openxmlformats.org/drawingml/2006/main" xmlns:r="http://schemas.openxmlformats.org/officeDocument/2006/relationships" xmlns:p="http://schemas.openxmlformats.org/presentationml/2006/main">
   <p:cSld>
+    <p:bg>
+      <p:bgPr>
+        <a:solidFill>
+          <a:schemeClr val="accent1">
+            <a:alpha val="0"/>
+          </a:schemeClr>
+        </a:solidFill>
+        <a:effectLst/>
+      </p:bgPr>
+    </p:bg>
     <p:spTree>
       <p:nvGrpSpPr>
         <p:cNvPr id="1" name=""/>
@@ -9930,6 +9967,16 @@
 <file path=ppt/slides/slide6.xml><?xml version="1.0" encoding="utf-8"?>
 <p:sld xmlns:a="http://schemas.openxmlformats.org/drawingml/2006/main" xmlns:r="http://schemas.openxmlformats.org/officeDocument/2006/relationships" xmlns:p="http://schemas.openxmlformats.org/presentationml/2006/main">
   <p:cSld>
+    <p:bg>
+      <p:bgPr>
+        <a:solidFill>
+          <a:schemeClr val="accent1">
+            <a:alpha val="0"/>
+          </a:schemeClr>
+        </a:solidFill>
+        <a:effectLst/>
+      </p:bgPr>
+    </p:bg>
     <p:spTree>
       <p:nvGrpSpPr>
         <p:cNvPr id="1" name=""/>
@@ -10258,6 +10305,16 @@
 <file path=ppt/slides/slide7.xml><?xml version="1.0" encoding="utf-8"?>
 <p:sld xmlns:a="http://schemas.openxmlformats.org/drawingml/2006/main" xmlns:r="http://schemas.openxmlformats.org/officeDocument/2006/relationships" xmlns:p="http://schemas.openxmlformats.org/presentationml/2006/main">
   <p:cSld>
+    <p:bg>
+      <p:bgPr>
+        <a:solidFill>
+          <a:schemeClr val="accent1">
+            <a:alpha val="0"/>
+          </a:schemeClr>
+        </a:solidFill>
+        <a:effectLst/>
+      </p:bgPr>
+    </p:bg>
     <p:spTree>
       <p:nvGrpSpPr>
         <p:cNvPr id="1" name=""/>
@@ -10661,6 +10718,449 @@
     <p:extLst>
       <p:ext uri="{BB962C8B-B14F-4D97-AF65-F5344CB8AC3E}">
         <p14:creationId xmlns:p14="http://schemas.microsoft.com/office/powerpoint/2010/main" val="4057779969"/>
+      </p:ext>
+    </p:extLst>
+  </p:cSld>
+  <p:clrMapOvr>
+    <a:masterClrMapping/>
+  </p:clrMapOvr>
+</p:sld>
+</file>
+
+<file path=ppt/slides/slide8.xml><?xml version="1.0" encoding="utf-8"?>
+<p:sld xmlns:a="http://schemas.openxmlformats.org/drawingml/2006/main" xmlns:r="http://schemas.openxmlformats.org/officeDocument/2006/relationships" xmlns:p="http://schemas.openxmlformats.org/presentationml/2006/main">
+  <p:cSld>
+    <p:bg>
+      <p:bgPr>
+        <a:solidFill>
+          <a:schemeClr val="accent1">
+            <a:alpha val="0"/>
+          </a:schemeClr>
+        </a:solidFill>
+        <a:effectLst/>
+      </p:bgPr>
+    </p:bg>
+    <p:spTree>
+      <p:nvGrpSpPr>
+        <p:cNvPr id="1" name=""/>
+        <p:cNvGrpSpPr/>
+        <p:nvPr/>
+      </p:nvGrpSpPr>
+      <p:grpSpPr>
+        <a:xfrm>
+          <a:off x="0" y="0"/>
+          <a:ext cx="0" cy="0"/>
+          <a:chOff x="0" y="0"/>
+          <a:chExt cx="0" cy="0"/>
+        </a:xfrm>
+      </p:grpSpPr>
+      <p:sp>
+        <p:nvSpPr>
+          <p:cNvPr id="2" name="Título 1">
+            <a:extLst>
+              <a:ext uri="{FF2B5EF4-FFF2-40B4-BE49-F238E27FC236}">
+                <a16:creationId xmlns:a16="http://schemas.microsoft.com/office/drawing/2014/main" id="{AA434B60-06E8-5CD4-FE2C-351E93E5B27B}"/>
+              </a:ext>
+            </a:extLst>
+          </p:cNvPr>
+          <p:cNvSpPr>
+            <a:spLocks noGrp="1"/>
+          </p:cNvSpPr>
+          <p:nvPr>
+            <p:ph type="title"/>
+          </p:nvPr>
+        </p:nvSpPr>
+        <p:spPr>
+          <a:xfrm>
+            <a:off x="1739485" y="633803"/>
+            <a:ext cx="8911687" cy="1280890"/>
+          </a:xfrm>
+        </p:spPr>
+        <p:txBody>
+          <a:bodyPr/>
+          <a:lstStyle/>
+          <a:p>
+            <a:r>
+              <a:rPr lang="es-ES" dirty="0"/>
+              <a:t>Conclusiones y </a:t>
+            </a:r>
+            <a:r>
+              <a:rPr lang="es-ES" dirty="0" err="1"/>
+              <a:t>roadmap</a:t>
+            </a:r>
+            <a:endParaRPr lang="es-ES" dirty="0"/>
+          </a:p>
+        </p:txBody>
+      </p:sp>
+      <p:sp>
+        <p:nvSpPr>
+          <p:cNvPr id="4" name="CuadroTexto 3">
+            <a:extLst>
+              <a:ext uri="{FF2B5EF4-FFF2-40B4-BE49-F238E27FC236}">
+                <a16:creationId xmlns:a16="http://schemas.microsoft.com/office/drawing/2014/main" id="{BE8C11A6-D809-ED74-8552-295E767EE02D}"/>
+              </a:ext>
+            </a:extLst>
+          </p:cNvPr>
+          <p:cNvSpPr txBox="1"/>
+          <p:nvPr/>
+        </p:nvSpPr>
+        <p:spPr>
+          <a:xfrm>
+            <a:off x="2131475" y="1435081"/>
+            <a:ext cx="2997200" cy="3416320"/>
+          </a:xfrm>
+          <a:prstGeom prst="rect">
+            <a:avLst/>
+          </a:prstGeom>
+          <a:solidFill>
+            <a:srgbClr val="E1FBEA"/>
+          </a:solidFill>
+          <a:ln>
+            <a:solidFill>
+              <a:srgbClr val="45E980"/>
+            </a:solidFill>
+          </a:ln>
+        </p:spPr>
+        <p:txBody>
+          <a:bodyPr wrap="square" rtlCol="0">
+            <a:spAutoFit/>
+          </a:bodyPr>
+          <a:lstStyle/>
+          <a:p>
+            <a:r>
+              <a:rPr lang="es-ES" dirty="0"/>
+              <a:t>Completado</a:t>
+            </a:r>
+          </a:p>
+          <a:p>
+            <a:endParaRPr lang="es-ES" dirty="0"/>
+          </a:p>
+          <a:p>
+            <a:pPr marL="285750" indent="-285750">
+              <a:buFont typeface="Wingdings" panose="05000000000000000000" pitchFamily="2" charset="2"/>
+              <a:buChar char="ü"/>
+            </a:pPr>
+            <a:r>
+              <a:rPr lang="es-ES" dirty="0"/>
+              <a:t>TPV funcional</a:t>
+            </a:r>
+          </a:p>
+          <a:p>
+            <a:pPr marL="285750" indent="-285750">
+              <a:buFont typeface="Wingdings" panose="05000000000000000000" pitchFamily="2" charset="2"/>
+              <a:buChar char="ü"/>
+            </a:pPr>
+            <a:r>
+              <a:rPr lang="es-ES" dirty="0" err="1"/>
+              <a:t>Dashboard</a:t>
+            </a:r>
+            <a:r>
+              <a:rPr lang="es-ES" dirty="0"/>
+              <a:t> y estadísticas</a:t>
+            </a:r>
+          </a:p>
+          <a:p>
+            <a:pPr marL="285750" indent="-285750">
+              <a:buFont typeface="Wingdings" panose="05000000000000000000" pitchFamily="2" charset="2"/>
+              <a:buChar char="ü"/>
+            </a:pPr>
+            <a:r>
+              <a:rPr lang="es-ES" dirty="0"/>
+              <a:t>Roles y autenticación</a:t>
+            </a:r>
+          </a:p>
+          <a:p>
+            <a:pPr marL="285750" indent="-285750">
+              <a:buFont typeface="Wingdings" panose="05000000000000000000" pitchFamily="2" charset="2"/>
+              <a:buChar char="ü"/>
+            </a:pPr>
+            <a:r>
+              <a:rPr lang="es-ES" dirty="0"/>
+              <a:t>Email con PDF</a:t>
+            </a:r>
+          </a:p>
+          <a:p>
+            <a:pPr marL="285750" indent="-285750">
+              <a:buFont typeface="Wingdings" panose="05000000000000000000" pitchFamily="2" charset="2"/>
+              <a:buChar char="ü"/>
+            </a:pPr>
+            <a:r>
+              <a:rPr lang="es-ES" dirty="0"/>
+              <a:t>Informes de ingresos pdf</a:t>
+            </a:r>
+          </a:p>
+          <a:p>
+            <a:pPr marL="285750" indent="-285750">
+              <a:buFont typeface="Wingdings" panose="05000000000000000000" pitchFamily="2" charset="2"/>
+              <a:buChar char="ü"/>
+            </a:pPr>
+            <a:r>
+              <a:rPr lang="es-ES" dirty="0"/>
+              <a:t>Impresora térmica</a:t>
+            </a:r>
+          </a:p>
+          <a:p>
+            <a:pPr marL="285750" indent="-285750">
+              <a:buFont typeface="Wingdings" panose="05000000000000000000" pitchFamily="2" charset="2"/>
+              <a:buChar char="ü"/>
+            </a:pPr>
+            <a:r>
+              <a:rPr lang="es-ES" dirty="0"/>
+              <a:t>Modo oscuro</a:t>
+            </a:r>
+          </a:p>
+          <a:p>
+            <a:endParaRPr lang="es-ES" dirty="0"/>
+          </a:p>
+        </p:txBody>
+      </p:sp>
+      <p:sp>
+        <p:nvSpPr>
+          <p:cNvPr id="5" name="CuadroTexto 4">
+            <a:extLst>
+              <a:ext uri="{FF2B5EF4-FFF2-40B4-BE49-F238E27FC236}">
+                <a16:creationId xmlns:a16="http://schemas.microsoft.com/office/drawing/2014/main" id="{B0072965-2364-4762-89F0-A1456EB00FF3}"/>
+              </a:ext>
+            </a:extLst>
+          </p:cNvPr>
+          <p:cNvSpPr txBox="1"/>
+          <p:nvPr/>
+        </p:nvSpPr>
+        <p:spPr>
+          <a:xfrm>
+            <a:off x="6601875" y="1435081"/>
+            <a:ext cx="2997200" cy="3416320"/>
+          </a:xfrm>
+          <a:prstGeom prst="rect">
+            <a:avLst/>
+          </a:prstGeom>
+          <a:solidFill>
+            <a:srgbClr val="DDECFF"/>
+          </a:solidFill>
+          <a:ln>
+            <a:solidFill>
+              <a:srgbClr val="5EA5FC"/>
+            </a:solidFill>
+          </a:ln>
+        </p:spPr>
+        <p:txBody>
+          <a:bodyPr wrap="square" rtlCol="0">
+            <a:spAutoFit/>
+          </a:bodyPr>
+          <a:lstStyle/>
+          <a:p>
+            <a:r>
+              <a:rPr lang="es-ES" dirty="0"/>
+              <a:t>Próximas actualizaciones</a:t>
+            </a:r>
+          </a:p>
+          <a:p>
+            <a:endParaRPr lang="es-ES" dirty="0"/>
+          </a:p>
+          <a:p>
+            <a:pPr marL="285750" indent="-285750">
+              <a:buFont typeface="Wingdings" panose="05000000000000000000" pitchFamily="2" charset="2"/>
+              <a:buChar char="q"/>
+            </a:pPr>
+            <a:r>
+              <a:rPr lang="es-ES" dirty="0"/>
+              <a:t>Módulo gastos</a:t>
+            </a:r>
+          </a:p>
+          <a:p>
+            <a:pPr marL="285750" indent="-285750">
+              <a:buFont typeface="Wingdings" panose="05000000000000000000" pitchFamily="2" charset="2"/>
+              <a:buChar char="q"/>
+            </a:pPr>
+            <a:r>
+              <a:rPr lang="es-ES" dirty="0"/>
+              <a:t>Menú suplementos</a:t>
+            </a:r>
+          </a:p>
+          <a:p>
+            <a:pPr marL="285750" indent="-285750">
+              <a:buFont typeface="Wingdings" panose="05000000000000000000" pitchFamily="2" charset="2"/>
+              <a:buChar char="q"/>
+            </a:pPr>
+            <a:r>
+              <a:rPr lang="es-ES" dirty="0"/>
+              <a:t>Interfaz </a:t>
+            </a:r>
+            <a:r>
+              <a:rPr lang="es-ES" dirty="0" err="1"/>
+              <a:t>mobile</a:t>
+            </a:r>
+            <a:r>
+              <a:rPr lang="es-ES" dirty="0"/>
+              <a:t> responsive</a:t>
+            </a:r>
+          </a:p>
+          <a:p>
+            <a:pPr marL="285750" indent="-285750">
+              <a:buFont typeface="Wingdings" panose="05000000000000000000" pitchFamily="2" charset="2"/>
+              <a:buChar char="q"/>
+            </a:pPr>
+            <a:r>
+              <a:rPr lang="es-ES" dirty="0"/>
+              <a:t>Mejorar servidor de impresión</a:t>
+            </a:r>
+          </a:p>
+          <a:p>
+            <a:pPr marL="285750" indent="-285750">
+              <a:buFont typeface="Wingdings" panose="05000000000000000000" pitchFamily="2" charset="2"/>
+              <a:buChar char="q"/>
+            </a:pPr>
+            <a:r>
+              <a:rPr lang="es-ES" dirty="0"/>
+              <a:t>Mejorar seguridad en servidor de impresión</a:t>
+            </a:r>
+          </a:p>
+          <a:p>
+            <a:pPr marL="285750" indent="-285750">
+              <a:buFont typeface="Wingdings" panose="05000000000000000000" pitchFamily="2" charset="2"/>
+              <a:buChar char="q"/>
+            </a:pPr>
+            <a:r>
+              <a:rPr lang="es-ES" dirty="0"/>
+              <a:t>Accesibilidad</a:t>
+            </a:r>
+          </a:p>
+          <a:p>
+            <a:endParaRPr lang="es-ES" dirty="0"/>
+          </a:p>
+        </p:txBody>
+      </p:sp>
+      <p:sp>
+        <p:nvSpPr>
+          <p:cNvPr id="6" name="CuadroTexto 5">
+            <a:extLst>
+              <a:ext uri="{FF2B5EF4-FFF2-40B4-BE49-F238E27FC236}">
+                <a16:creationId xmlns:a16="http://schemas.microsoft.com/office/drawing/2014/main" id="{F53E27A2-660B-8F2E-6FA1-9B559F447101}"/>
+              </a:ext>
+            </a:extLst>
+          </p:cNvPr>
+          <p:cNvSpPr txBox="1"/>
+          <p:nvPr/>
+        </p:nvSpPr>
+        <p:spPr>
+          <a:xfrm>
+            <a:off x="2131475" y="5174794"/>
+            <a:ext cx="7467600" cy="1477328"/>
+          </a:xfrm>
+          <a:prstGeom prst="rect">
+            <a:avLst/>
+          </a:prstGeom>
+          <a:solidFill>
+            <a:srgbClr val="FEFCE8"/>
+          </a:solidFill>
+          <a:ln>
+            <a:solidFill>
+              <a:srgbClr val="FEF08A"/>
+            </a:solidFill>
+          </a:ln>
+        </p:spPr>
+        <p:txBody>
+          <a:bodyPr wrap="square" rtlCol="0">
+            <a:spAutoFit/>
+          </a:bodyPr>
+          <a:lstStyle/>
+          <a:p>
+            <a:r>
+              <a:rPr lang="es-ES" b="1" dirty="0"/>
+              <a:t>Lo que aprendí</a:t>
+            </a:r>
+          </a:p>
+          <a:p>
+            <a:endParaRPr lang="es-ES" dirty="0"/>
+          </a:p>
+          <a:p>
+            <a:r>
+              <a:rPr lang="es-ES" dirty="0"/>
+              <a:t>Integrar hardware local con una app en la nube me ha significado un gran reto para aplicar los conocimientos que he adquirido en este ciclo.</a:t>
+            </a:r>
+          </a:p>
+        </p:txBody>
+      </p:sp>
+    </p:spTree>
+    <p:extLst>
+      <p:ext uri="{BB962C8B-B14F-4D97-AF65-F5344CB8AC3E}">
+        <p14:creationId xmlns:p14="http://schemas.microsoft.com/office/powerpoint/2010/main" val="717725404"/>
+      </p:ext>
+    </p:extLst>
+  </p:cSld>
+  <p:clrMapOvr>
+    <a:masterClrMapping/>
+  </p:clrMapOvr>
+</p:sld>
+</file>
+
+<file path=ppt/slides/slide9.xml><?xml version="1.0" encoding="utf-8"?>
+<p:sld xmlns:a="http://schemas.openxmlformats.org/drawingml/2006/main" xmlns:r="http://schemas.openxmlformats.org/officeDocument/2006/relationships" xmlns:p="http://schemas.openxmlformats.org/presentationml/2006/main">
+  <p:cSld>
+    <p:bg>
+      <p:bgPr>
+        <a:solidFill>
+          <a:schemeClr val="accent1">
+            <a:alpha val="0"/>
+          </a:schemeClr>
+        </a:solidFill>
+        <a:effectLst/>
+      </p:bgPr>
+    </p:bg>
+    <p:spTree>
+      <p:nvGrpSpPr>
+        <p:cNvPr id="1" name=""/>
+        <p:cNvGrpSpPr/>
+        <p:nvPr/>
+      </p:nvGrpSpPr>
+      <p:grpSpPr>
+        <a:xfrm>
+          <a:off x="0" y="0"/>
+          <a:ext cx="0" cy="0"/>
+          <a:chOff x="0" y="0"/>
+          <a:chExt cx="0" cy="0"/>
+        </a:xfrm>
+      </p:grpSpPr>
+      <p:sp>
+        <p:nvSpPr>
+          <p:cNvPr id="4" name="CuadroTexto 3">
+            <a:extLst>
+              <a:ext uri="{FF2B5EF4-FFF2-40B4-BE49-F238E27FC236}">
+                <a16:creationId xmlns:a16="http://schemas.microsoft.com/office/drawing/2014/main" id="{AE865A7D-A78E-2C94-5E44-D14B42762577}"/>
+              </a:ext>
+            </a:extLst>
+          </p:cNvPr>
+          <p:cNvSpPr txBox="1"/>
+          <p:nvPr/>
+        </p:nvSpPr>
+        <p:spPr>
+          <a:xfrm>
+            <a:off x="1757680" y="1930400"/>
+            <a:ext cx="9469120" cy="2123658"/>
+          </a:xfrm>
+          <a:prstGeom prst="rect">
+            <a:avLst/>
+          </a:prstGeom>
+          <a:noFill/>
+        </p:spPr>
+        <p:txBody>
+          <a:bodyPr wrap="square" rtlCol="0">
+            <a:spAutoFit/>
+          </a:bodyPr>
+          <a:lstStyle/>
+          <a:p>
+            <a:pPr algn="ctr"/>
+            <a:r>
+              <a:rPr lang="es-ES" sz="6600" dirty="0"/>
+              <a:t>Gracias por su atención</a:t>
+            </a:r>
+          </a:p>
+        </p:txBody>
+      </p:sp>
+    </p:spTree>
+    <p:extLst>
+      <p:ext uri="{BB962C8B-B14F-4D97-AF65-F5344CB8AC3E}">
+        <p14:creationId xmlns:p14="http://schemas.microsoft.com/office/powerpoint/2010/main" val="152498127"/>
       </p:ext>
     </p:extLst>
   </p:cSld>

</xml_diff>

<commit_message>
docs: actualizado presentacion y exportado a pdf
</commit_message>
<xml_diff>
--- a/documentacion proyecto/Presentacion_proyecto.pptx
+++ b/documentacion proyecto/Presentacion_proyecto.pptx
@@ -308,7 +308,7 @@
           <a:p>
             <a:fld id="{7DA38F49-B3E2-4BF0-BEC7-C30D34ABBB8D}" type="datetime1">
               <a:rPr lang="en-US" smtClean="0"/>
-              <a:t>5/14/2026</a:t>
+              <a:t>5/18/2026</a:t>
             </a:fld>
             <a:endParaRPr lang="en-US"/>
           </a:p>
@@ -654,7 +654,7 @@
           <a:p>
             <a:fld id="{7DA38F49-B3E2-4BF0-BEC7-C30D34ABBB8D}" type="datetime1">
               <a:rPr lang="en-US" smtClean="0"/>
-              <a:t>5/14/2026</a:t>
+              <a:t>5/18/2026</a:t>
             </a:fld>
             <a:endParaRPr lang="en-US"/>
           </a:p>
@@ -1056,7 +1056,7 @@
           <a:p>
             <a:fld id="{7DA38F49-B3E2-4BF0-BEC7-C30D34ABBB8D}" type="datetime1">
               <a:rPr lang="en-US" smtClean="0"/>
-              <a:t>5/14/2026</a:t>
+              <a:t>5/18/2026</a:t>
             </a:fld>
             <a:endParaRPr lang="en-US"/>
           </a:p>
@@ -1393,7 +1393,7 @@
           <a:p>
             <a:fld id="{7DA38F49-B3E2-4BF0-BEC7-C30D34ABBB8D}" type="datetime1">
               <a:rPr lang="en-US" smtClean="0"/>
-              <a:t>5/14/2026</a:t>
+              <a:t>5/18/2026</a:t>
             </a:fld>
             <a:endParaRPr lang="en-US"/>
           </a:p>
@@ -1714,7 +1714,7 @@
           <a:p>
             <a:fld id="{7DA38F49-B3E2-4BF0-BEC7-C30D34ABBB8D}" type="datetime1">
               <a:rPr lang="en-US" smtClean="0"/>
-              <a:t>5/14/2026</a:t>
+              <a:t>5/18/2026</a:t>
             </a:fld>
             <a:endParaRPr lang="en-US"/>
           </a:p>
@@ -2111,7 +2111,7 @@
           <a:p>
             <a:fld id="{7DA38F49-B3E2-4BF0-BEC7-C30D34ABBB8D}" type="datetime1">
               <a:rPr lang="en-US" smtClean="0"/>
-              <a:t>5/14/2026</a:t>
+              <a:t>5/18/2026</a:t>
             </a:fld>
             <a:endParaRPr lang="en-US"/>
           </a:p>
@@ -2369,7 +2369,7 @@
           <a:p>
             <a:fld id="{7DA38F49-B3E2-4BF0-BEC7-C30D34ABBB8D}" type="datetime1">
               <a:rPr lang="en-US" smtClean="0"/>
-              <a:t>5/14/2026</a:t>
+              <a:t>5/18/2026</a:t>
             </a:fld>
             <a:endParaRPr lang="en-US"/>
           </a:p>
@@ -2632,7 +2632,7 @@
           <a:p>
             <a:fld id="{7DA38F49-B3E2-4BF0-BEC7-C30D34ABBB8D}" type="datetime1">
               <a:rPr lang="en-US" smtClean="0"/>
-              <a:t>5/14/2026</a:t>
+              <a:t>5/18/2026</a:t>
             </a:fld>
             <a:endParaRPr lang="en-US"/>
           </a:p>
@@ -2895,7 +2895,7 @@
           <a:p>
             <a:fld id="{7DA38F49-B3E2-4BF0-BEC7-C30D34ABBB8D}" type="datetime1">
               <a:rPr lang="en-US" smtClean="0"/>
-              <a:t>5/14/2026</a:t>
+              <a:t>5/18/2026</a:t>
             </a:fld>
             <a:endParaRPr lang="en-US"/>
           </a:p>
@@ -3225,7 +3225,7 @@
           <a:p>
             <a:fld id="{7DA38F49-B3E2-4BF0-BEC7-C30D34ABBB8D}" type="datetime1">
               <a:rPr lang="en-US" smtClean="0"/>
-              <a:t>5/14/2026</a:t>
+              <a:t>5/18/2026</a:t>
             </a:fld>
             <a:endParaRPr lang="en-US"/>
           </a:p>
@@ -3549,7 +3549,7 @@
           <a:p>
             <a:fld id="{7DA38F49-B3E2-4BF0-BEC7-C30D34ABBB8D}" type="datetime1">
               <a:rPr lang="en-US" smtClean="0"/>
-              <a:t>5/14/2026</a:t>
+              <a:t>5/18/2026</a:t>
             </a:fld>
             <a:endParaRPr lang="en-US"/>
           </a:p>
@@ -4007,7 +4007,7 @@
           <a:p>
             <a:fld id="{7DA38F49-B3E2-4BF0-BEC7-C30D34ABBB8D}" type="datetime1">
               <a:rPr lang="en-US" smtClean="0"/>
-              <a:t>5/14/2026</a:t>
+              <a:t>5/18/2026</a:t>
             </a:fld>
             <a:endParaRPr lang="en-US"/>
           </a:p>
@@ -4213,7 +4213,7 @@
           <a:p>
             <a:fld id="{7DA38F49-B3E2-4BF0-BEC7-C30D34ABBB8D}" type="datetime1">
               <a:rPr lang="en-US" smtClean="0"/>
-              <a:t>5/14/2026</a:t>
+              <a:t>5/18/2026</a:t>
             </a:fld>
             <a:endParaRPr lang="en-US"/>
           </a:p>
@@ -4391,7 +4391,7 @@
           <a:p>
             <a:fld id="{7DA38F49-B3E2-4BF0-BEC7-C30D34ABBB8D}" type="datetime1">
               <a:rPr lang="en-US" smtClean="0"/>
-              <a:t>5/14/2026</a:t>
+              <a:t>5/18/2026</a:t>
             </a:fld>
             <a:endParaRPr lang="en-US"/>
           </a:p>
@@ -4725,7 +4725,7 @@
           <a:p>
             <a:fld id="{7DA38F49-B3E2-4BF0-BEC7-C30D34ABBB8D}" type="datetime1">
               <a:rPr lang="en-US" smtClean="0"/>
-              <a:t>5/14/2026</a:t>
+              <a:t>5/18/2026</a:t>
             </a:fld>
             <a:endParaRPr lang="en-US"/>
           </a:p>
@@ -5071,7 +5071,7 @@
           <a:p>
             <a:fld id="{7DA38F49-B3E2-4BF0-BEC7-C30D34ABBB8D}" type="datetime1">
               <a:rPr lang="en-US" smtClean="0"/>
-              <a:t>5/14/2026</a:t>
+              <a:t>5/18/2026</a:t>
             </a:fld>
             <a:endParaRPr lang="en-US"/>
           </a:p>
@@ -7364,7 +7364,7 @@
           <a:p>
             <a:fld id="{7DA38F49-B3E2-4BF0-BEC7-C30D34ABBB8D}" type="datetime1">
               <a:rPr lang="en-US" smtClean="0"/>
-              <a:t>5/14/2026</a:t>
+              <a:t>5/18/2026</a:t>
             </a:fld>
             <a:endParaRPr lang="en-US"/>
           </a:p>
@@ -11021,8 +11021,12 @@
               <a:buChar char="q"/>
             </a:pPr>
             <a:r>
+              <a:rPr lang="es-ES" dirty="0" err="1"/>
+              <a:t>Multidioma</a:t>
+            </a:r>
+            <a:r>
               <a:rPr lang="es-ES" dirty="0"/>
-              <a:t>Accesibilidad</a:t>
+              <a:t> - i18n</a:t>
             </a:r>
           </a:p>
           <a:p>

</xml_diff>